<commit_message>
Organizing Code into seperate cpp files
</commit_message>
<xml_diff>
--- a/Presentation/Project_Update_(8-12).pptx
+++ b/Presentation/Project_Update_(8-12).pptx
@@ -6,12 +6,17 @@
     <p:sldMasterId id="2147483674" r:id="rId2"/>
   </p:sldMasterIdLst>
   <p:notesMasterIdLst>
-    <p:notesMasterId r:id="rId6"/>
+    <p:notesMasterId r:id="rId11"/>
   </p:notesMasterIdLst>
   <p:sldIdLst>
     <p:sldId id="3588" r:id="rId3"/>
-    <p:sldId id="3620" r:id="rId4"/>
-    <p:sldId id="3621" r:id="rId5"/>
+    <p:sldId id="3621" r:id="rId4"/>
+    <p:sldId id="3592" r:id="rId5"/>
+    <p:sldId id="3623" r:id="rId6"/>
+    <p:sldId id="3625" r:id="rId7"/>
+    <p:sldId id="3624" r:id="rId8"/>
+    <p:sldId id="3626" r:id="rId9"/>
+    <p:sldId id="3622" r:id="rId10"/>
   </p:sldIdLst>
   <p:sldSz cx="9144000" cy="6858000" type="screen4x3"/>
   <p:notesSz cx="6858000" cy="9144000"/>
@@ -200,7 +205,7 @@
           <a:p>
             <a:fld id="{42297E26-78EB-8B41-8DC9-A0EBC93E0939}" type="datetimeFigureOut">
               <a:rPr lang="en-US" smtClean="0"/>
-              <a:t>9/5/2025</a:t>
+              <a:t>9/19/2025</a:t>
             </a:fld>
             <a:endParaRPr lang="en-US"/>
           </a:p>
@@ -885,7 +890,7 @@
     </p:spTree>
     <p:extLst>
       <p:ext uri="{BB962C8B-B14F-4D97-AF65-F5344CB8AC3E}">
-        <p14:creationId xmlns:p14="http://schemas.microsoft.com/office/powerpoint/2010/main" val="926004251"/>
+        <p14:creationId xmlns:p14="http://schemas.microsoft.com/office/powerpoint/2010/main" val="1996327844"/>
       </p:ext>
     </p:extLst>
   </p:cSld>
@@ -903,7 +908,7 @@
         <p:cNvPr id="1" name="">
           <a:extLst>
             <a:ext uri="{FF2B5EF4-FFF2-40B4-BE49-F238E27FC236}">
-              <a16:creationId xmlns:a16="http://schemas.microsoft.com/office/drawing/2014/main" id="{48979CB3-A21A-DE50-0904-6AA80D8C2B2C}"/>
+              <a16:creationId xmlns:a16="http://schemas.microsoft.com/office/drawing/2014/main" id="{775683DD-A8C1-710B-5E6C-D5F5A84D834F}"/>
             </a:ext>
           </a:extLst>
         </p:cNvPr>
@@ -923,7 +928,7 @@
           <p:cNvPr id="2" name="Slide Image Placeholder 1">
             <a:extLst>
               <a:ext uri="{FF2B5EF4-FFF2-40B4-BE49-F238E27FC236}">
-                <a16:creationId xmlns:a16="http://schemas.microsoft.com/office/drawing/2014/main" id="{B8EF8597-08D6-674A-D533-50F013ADF1AE}"/>
+                <a16:creationId xmlns:a16="http://schemas.microsoft.com/office/drawing/2014/main" id="{C3D2A36D-ACA9-D2A0-54EE-5255CBE0B338}"/>
               </a:ext>
             </a:extLst>
           </p:cNvPr>
@@ -941,7 +946,7 @@
           <p:cNvPr id="3" name="Notes Placeholder 2">
             <a:extLst>
               <a:ext uri="{FF2B5EF4-FFF2-40B4-BE49-F238E27FC236}">
-                <a16:creationId xmlns:a16="http://schemas.microsoft.com/office/drawing/2014/main" id="{4A02F682-F949-EFC3-C6B2-20CF0E2DF4F5}"/>
+                <a16:creationId xmlns:a16="http://schemas.microsoft.com/office/drawing/2014/main" id="{3F4518B0-E444-FBC8-EFE3-D7C1567F5692}"/>
               </a:ext>
             </a:extLst>
           </p:cNvPr>
@@ -1191,7 +1196,7 @@
           <p:cNvPr id="4" name="Slide Number Placeholder 3">
             <a:extLst>
               <a:ext uri="{FF2B5EF4-FFF2-40B4-BE49-F238E27FC236}">
-                <a16:creationId xmlns:a16="http://schemas.microsoft.com/office/drawing/2014/main" id="{5BC16D41-3CD0-2053-0DDC-56987738770A}"/>
+                <a16:creationId xmlns:a16="http://schemas.microsoft.com/office/drawing/2014/main" id="{241864D2-5790-DA76-6EC4-9F843DA6A508}"/>
               </a:ext>
             </a:extLst>
           </p:cNvPr>
@@ -1218,7 +1223,1222 @@
     </p:spTree>
     <p:extLst>
       <p:ext uri="{BB962C8B-B14F-4D97-AF65-F5344CB8AC3E}">
-        <p14:creationId xmlns:p14="http://schemas.microsoft.com/office/powerpoint/2010/main" val="1996327844"/>
+        <p14:creationId xmlns:p14="http://schemas.microsoft.com/office/powerpoint/2010/main" val="3325502898"/>
+      </p:ext>
+    </p:extLst>
+  </p:cSld>
+  <p:clrMapOvr>
+    <a:masterClrMapping/>
+  </p:clrMapOvr>
+</p:notes>
+</file>
+
+<file path=ppt/notesSlides/notesSlide4.xml><?xml version="1.0" encoding="utf-8"?>
+<p:notes xmlns:a="http://schemas.openxmlformats.org/drawingml/2006/main" xmlns:r="http://schemas.openxmlformats.org/officeDocument/2006/relationships" xmlns:p="http://schemas.openxmlformats.org/presentationml/2006/main">
+  <p:cSld>
+    <p:spTree>
+      <p:nvGrpSpPr>
+        <p:cNvPr id="1" name="">
+          <a:extLst>
+            <a:ext uri="{FF2B5EF4-FFF2-40B4-BE49-F238E27FC236}">
+              <a16:creationId xmlns:a16="http://schemas.microsoft.com/office/drawing/2014/main" id="{C2862B51-A798-C10D-42D1-BF74C95CFED2}"/>
+            </a:ext>
+          </a:extLst>
+        </p:cNvPr>
+        <p:cNvGrpSpPr/>
+        <p:nvPr/>
+      </p:nvGrpSpPr>
+      <p:grpSpPr>
+        <a:xfrm>
+          <a:off x="0" y="0"/>
+          <a:ext cx="0" cy="0"/>
+          <a:chOff x="0" y="0"/>
+          <a:chExt cx="0" cy="0"/>
+        </a:xfrm>
+      </p:grpSpPr>
+      <p:sp>
+        <p:nvSpPr>
+          <p:cNvPr id="2" name="Slide Image Placeholder 1">
+            <a:extLst>
+              <a:ext uri="{FF2B5EF4-FFF2-40B4-BE49-F238E27FC236}">
+                <a16:creationId xmlns:a16="http://schemas.microsoft.com/office/drawing/2014/main" id="{E095A781-99AC-484D-9687-8E4ECDFDD093}"/>
+              </a:ext>
+            </a:extLst>
+          </p:cNvPr>
+          <p:cNvSpPr>
+            <a:spLocks noGrp="1" noRot="1" noChangeAspect="1"/>
+          </p:cNvSpPr>
+          <p:nvPr>
+            <p:ph type="sldImg"/>
+          </p:nvPr>
+        </p:nvSpPr>
+        <p:spPr/>
+      </p:sp>
+      <p:sp>
+        <p:nvSpPr>
+          <p:cNvPr id="3" name="Notes Placeholder 2">
+            <a:extLst>
+              <a:ext uri="{FF2B5EF4-FFF2-40B4-BE49-F238E27FC236}">
+                <a16:creationId xmlns:a16="http://schemas.microsoft.com/office/drawing/2014/main" id="{D5ACDAE2-9AED-1D4B-9792-25E01B5A1247}"/>
+              </a:ext>
+            </a:extLst>
+          </p:cNvPr>
+          <p:cNvSpPr>
+            <a:spLocks noGrp="1"/>
+          </p:cNvSpPr>
+          <p:nvPr>
+            <p:ph type="body" idx="1"/>
+          </p:nvPr>
+        </p:nvSpPr>
+        <p:spPr/>
+        <p:txBody>
+          <a:bodyPr/>
+          <a:lstStyle/>
+          <a:p>
+            <a:pPr marL="0" marR="0" lvl="0" indent="0" algn="l" defTabSz="914400" rtl="0" eaLnBrk="1" fontAlgn="auto" latinLnBrk="0" hangingPunct="1">
+              <a:lnSpc>
+                <a:spcPct val="100000"/>
+              </a:lnSpc>
+              <a:spcBef>
+                <a:spcPts val="0"/>
+              </a:spcBef>
+              <a:spcAft>
+                <a:spcPts val="0"/>
+              </a:spcAft>
+              <a:buClrTx/>
+              <a:buSzTx/>
+              <a:buFontTx/>
+              <a:buNone/>
+              <a:tabLst/>
+              <a:defRPr/>
+            </a:pPr>
+            <a:r>
+              <a:rPr lang="en-US" dirty="0"/>
+              <a:t>Pancreatic Ductal Adenocarcinoma is the most common subtype of pancreatic cancer, constituting about 90% of all pancreatic cancer. PDAC is the third leading cause of cancer-related deaths in the U.S., with a 5-year survival rate of only 13.3%. It is also known to have extremely poor prognosis, with nearly 90% of tumors already metastasized at diagnosis. </a:t>
+            </a:r>
+          </a:p>
+          <a:p>
+            <a:pPr marL="0" marR="0" lvl="0" indent="0" algn="l" defTabSz="914400" rtl="0" eaLnBrk="1" fontAlgn="auto" latinLnBrk="0" hangingPunct="1">
+              <a:lnSpc>
+                <a:spcPct val="100000"/>
+              </a:lnSpc>
+              <a:spcBef>
+                <a:spcPts val="0"/>
+              </a:spcBef>
+              <a:spcAft>
+                <a:spcPts val="0"/>
+              </a:spcAft>
+              <a:buClrTx/>
+              <a:buSzTx/>
+              <a:buFontTx/>
+              <a:buNone/>
+              <a:tabLst/>
+              <a:defRPr/>
+            </a:pPr>
+            <a:endParaRPr lang="en-US" dirty="0"/>
+          </a:p>
+          <a:p>
+            <a:pPr marL="0" marR="0" lvl="0" indent="0" algn="l" defTabSz="914400" rtl="0" eaLnBrk="1" fontAlgn="auto" latinLnBrk="0" hangingPunct="1">
+              <a:lnSpc>
+                <a:spcPct val="100000"/>
+              </a:lnSpc>
+              <a:spcBef>
+                <a:spcPts val="0"/>
+              </a:spcBef>
+              <a:spcAft>
+                <a:spcPts val="0"/>
+              </a:spcAft>
+              <a:buClrTx/>
+              <a:buSzTx/>
+              <a:buFontTx/>
+              <a:buNone/>
+              <a:tabLst/>
+              <a:defRPr/>
+            </a:pPr>
+            <a:endParaRPr lang="en-US" dirty="0"/>
+          </a:p>
+          <a:p>
+            <a:pPr marL="0" marR="0" lvl="0" indent="0" algn="l" defTabSz="914400" rtl="0" eaLnBrk="1" fontAlgn="auto" latinLnBrk="0" hangingPunct="1">
+              <a:lnSpc>
+                <a:spcPct val="100000"/>
+              </a:lnSpc>
+              <a:spcBef>
+                <a:spcPts val="0"/>
+              </a:spcBef>
+              <a:spcAft>
+                <a:spcPts val="0"/>
+              </a:spcAft>
+              <a:buClrTx/>
+              <a:buSzTx/>
+              <a:buFontTx/>
+              <a:buNone/>
+              <a:tabLst/>
+              <a:defRPr/>
+            </a:pPr>
+            <a:endParaRPr lang="en-US" dirty="0"/>
+          </a:p>
+          <a:p>
+            <a:pPr marL="0" marR="0" lvl="0" indent="0" algn="l" defTabSz="914400" rtl="0" eaLnBrk="1" fontAlgn="auto" latinLnBrk="0" hangingPunct="1">
+              <a:lnSpc>
+                <a:spcPct val="100000"/>
+              </a:lnSpc>
+              <a:spcBef>
+                <a:spcPts val="0"/>
+              </a:spcBef>
+              <a:spcAft>
+                <a:spcPts val="0"/>
+              </a:spcAft>
+              <a:buClrTx/>
+              <a:buSzTx/>
+              <a:buFontTx/>
+              <a:buNone/>
+              <a:tabLst/>
+              <a:defRPr/>
+            </a:pPr>
+            <a:endParaRPr lang="en-US" dirty="0"/>
+          </a:p>
+          <a:p>
+            <a:pPr marL="0" marR="0" lvl="0" indent="0" algn="l" defTabSz="914400" rtl="0" eaLnBrk="1" fontAlgn="auto" latinLnBrk="0" hangingPunct="1">
+              <a:lnSpc>
+                <a:spcPct val="100000"/>
+              </a:lnSpc>
+              <a:spcBef>
+                <a:spcPts val="0"/>
+              </a:spcBef>
+              <a:spcAft>
+                <a:spcPts val="0"/>
+              </a:spcAft>
+              <a:buClrTx/>
+              <a:buSzTx/>
+              <a:buFontTx/>
+              <a:buNone/>
+              <a:tabLst/>
+              <a:defRPr/>
+            </a:pPr>
+            <a:r>
+              <a:rPr lang="en-US" dirty="0"/>
+              <a:t>PDAC begins in the epithelial cells lining the pancreatic ducts, which are normally responsible for regulating secretion of digestive enzymes into the small intestine. In PDAC, these cells acquire mutations that cause them to proliferate uncontrollably and eventually rupture the ductal membrane. After spreading into the stroma, cancer-associated fibroblasts develop dense networks of collogen fibers, known as desmoplasia, around the previous pancreatic ducts. This creates almost like a shield around the tumor, protecting it from immune attack and drug penetration. </a:t>
+            </a:r>
+          </a:p>
+          <a:p>
+            <a:pPr marL="0" marR="0" lvl="0" indent="0" algn="l" defTabSz="914400" rtl="0" eaLnBrk="1" fontAlgn="auto" latinLnBrk="0" hangingPunct="1">
+              <a:lnSpc>
+                <a:spcPct val="100000"/>
+              </a:lnSpc>
+              <a:spcBef>
+                <a:spcPts val="0"/>
+              </a:spcBef>
+              <a:spcAft>
+                <a:spcPts val="0"/>
+              </a:spcAft>
+              <a:buClrTx/>
+              <a:buSzTx/>
+              <a:buFontTx/>
+              <a:buNone/>
+              <a:tabLst/>
+              <a:defRPr/>
+            </a:pPr>
+            <a:endParaRPr lang="en-US" dirty="0"/>
+          </a:p>
+          <a:p>
+            <a:pPr marL="0" marR="0" lvl="0" indent="0" algn="l" defTabSz="914400" rtl="0" eaLnBrk="1" fontAlgn="auto" latinLnBrk="0" hangingPunct="1">
+              <a:lnSpc>
+                <a:spcPct val="100000"/>
+              </a:lnSpc>
+              <a:spcBef>
+                <a:spcPts val="0"/>
+              </a:spcBef>
+              <a:spcAft>
+                <a:spcPts val="0"/>
+              </a:spcAft>
+              <a:buClrTx/>
+              <a:buSzTx/>
+              <a:buFontTx/>
+              <a:buNone/>
+              <a:tabLst/>
+              <a:defRPr/>
+            </a:pPr>
+            <a:r>
+              <a:rPr lang="en-US" dirty="0"/>
+              <a:t>Pancreatic ductal adenocarcinoma is the most common subtype of pancreatic cancer, with a 5 year survival rate of only 13%. The low survival rate is thought to be due to multiple challenges to treatment such as the difficulty of detecting PDAC before it has metastasized. (add graphic) A hallmark of PDAC is what’s called a “desmoplastic” tumor microenvironment. Compared to healthy tissue on the left, PDAC on the right has masses of cell growth in places that used to be healthy ducts, and is infiltrated by a greater diversity of immune and stromal cells while being crisscrossed and encapsulated in this network of collagen fibers, which are deposited by cancer-associated fibroblasts. </a:t>
+            </a:r>
+            <a:r>
+              <a:rPr lang="en-US" sz="1200" dirty="0"/>
+              <a:t>The dense fibrotic network of collagen is referred to as desmoplasia and is seen in certain types of tumors.</a:t>
+            </a:r>
+            <a:endParaRPr lang="en-US" dirty="0"/>
+          </a:p>
+          <a:p>
+            <a:pPr marL="0" marR="0" lvl="0" indent="0" algn="l" defTabSz="914400" rtl="0" eaLnBrk="1" fontAlgn="auto" latinLnBrk="0" hangingPunct="1">
+              <a:lnSpc>
+                <a:spcPct val="100000"/>
+              </a:lnSpc>
+              <a:spcBef>
+                <a:spcPts val="0"/>
+              </a:spcBef>
+              <a:spcAft>
+                <a:spcPts val="0"/>
+              </a:spcAft>
+              <a:buClrTx/>
+              <a:buSzTx/>
+              <a:buFontTx/>
+              <a:buNone/>
+              <a:tabLst/>
+              <a:defRPr/>
+            </a:pPr>
+            <a:endParaRPr lang="en-US" dirty="0"/>
+          </a:p>
+          <a:p>
+            <a:pPr marL="0" marR="0" lvl="0" indent="0" algn="l" defTabSz="914400" rtl="0" eaLnBrk="1" fontAlgn="auto" latinLnBrk="0" hangingPunct="1">
+              <a:lnSpc>
+                <a:spcPct val="100000"/>
+              </a:lnSpc>
+              <a:spcBef>
+                <a:spcPts val="0"/>
+              </a:spcBef>
+              <a:spcAft>
+                <a:spcPts val="0"/>
+              </a:spcAft>
+              <a:buClrTx/>
+              <a:buSzTx/>
+              <a:buFontTx/>
+              <a:buNone/>
+              <a:tabLst/>
+              <a:defRPr/>
+            </a:pPr>
+            <a:r>
+              <a:rPr lang="en-US" dirty="0"/>
+              <a:t>Those immune cells that are found in this microenvironment are often suppressive such as T regulatory cells and suppressive macrophages. Some of the immune cells are “residents” that were probably there in the healthy tissue, but others are recruited from the periphery (</a:t>
+            </a:r>
+            <a:r>
+              <a:rPr lang="en-US" dirty="0" err="1"/>
+              <a:t>BM+blood</a:t>
+            </a:r>
+            <a:r>
+              <a:rPr lang="en-US" dirty="0"/>
+              <a:t>)</a:t>
+            </a:r>
+          </a:p>
+          <a:p>
+            <a:endParaRPr lang="en-US" dirty="0"/>
+          </a:p>
+        </p:txBody>
+      </p:sp>
+      <p:sp>
+        <p:nvSpPr>
+          <p:cNvPr id="4" name="Slide Number Placeholder 3">
+            <a:extLst>
+              <a:ext uri="{FF2B5EF4-FFF2-40B4-BE49-F238E27FC236}">
+                <a16:creationId xmlns:a16="http://schemas.microsoft.com/office/drawing/2014/main" id="{34848C73-EDA6-51D9-D213-CF061EFAE17A}"/>
+              </a:ext>
+            </a:extLst>
+          </p:cNvPr>
+          <p:cNvSpPr>
+            <a:spLocks noGrp="1"/>
+          </p:cNvSpPr>
+          <p:nvPr>
+            <p:ph type="sldNum" sz="quarter" idx="5"/>
+          </p:nvPr>
+        </p:nvSpPr>
+        <p:spPr/>
+        <p:txBody>
+          <a:bodyPr/>
+          <a:lstStyle/>
+          <a:p>
+            <a:fld id="{B314B106-72D9-394B-AE7F-13630EA62899}" type="slidenum">
+              <a:rPr lang="en-US" smtClean="0"/>
+              <a:t>4</a:t>
+            </a:fld>
+            <a:endParaRPr lang="en-US"/>
+          </a:p>
+        </p:txBody>
+      </p:sp>
+    </p:spTree>
+    <p:extLst>
+      <p:ext uri="{BB962C8B-B14F-4D97-AF65-F5344CB8AC3E}">
+        <p14:creationId xmlns:p14="http://schemas.microsoft.com/office/powerpoint/2010/main" val="476236858"/>
+      </p:ext>
+    </p:extLst>
+  </p:cSld>
+  <p:clrMapOvr>
+    <a:masterClrMapping/>
+  </p:clrMapOvr>
+</p:notes>
+</file>
+
+<file path=ppt/notesSlides/notesSlide5.xml><?xml version="1.0" encoding="utf-8"?>
+<p:notes xmlns:a="http://schemas.openxmlformats.org/drawingml/2006/main" xmlns:r="http://schemas.openxmlformats.org/officeDocument/2006/relationships" xmlns:p="http://schemas.openxmlformats.org/presentationml/2006/main">
+  <p:cSld>
+    <p:spTree>
+      <p:nvGrpSpPr>
+        <p:cNvPr id="1" name="">
+          <a:extLst>
+            <a:ext uri="{FF2B5EF4-FFF2-40B4-BE49-F238E27FC236}">
+              <a16:creationId xmlns:a16="http://schemas.microsoft.com/office/drawing/2014/main" id="{064A4C81-4BE4-C24A-570A-47CEBEE334B2}"/>
+            </a:ext>
+          </a:extLst>
+        </p:cNvPr>
+        <p:cNvGrpSpPr/>
+        <p:nvPr/>
+      </p:nvGrpSpPr>
+      <p:grpSpPr>
+        <a:xfrm>
+          <a:off x="0" y="0"/>
+          <a:ext cx="0" cy="0"/>
+          <a:chOff x="0" y="0"/>
+          <a:chExt cx="0" cy="0"/>
+        </a:xfrm>
+      </p:grpSpPr>
+      <p:sp>
+        <p:nvSpPr>
+          <p:cNvPr id="2" name="Slide Image Placeholder 1">
+            <a:extLst>
+              <a:ext uri="{FF2B5EF4-FFF2-40B4-BE49-F238E27FC236}">
+                <a16:creationId xmlns:a16="http://schemas.microsoft.com/office/drawing/2014/main" id="{F2012475-B792-3A39-1C19-2A26A5217BA6}"/>
+              </a:ext>
+            </a:extLst>
+          </p:cNvPr>
+          <p:cNvSpPr>
+            <a:spLocks noGrp="1" noRot="1" noChangeAspect="1"/>
+          </p:cNvSpPr>
+          <p:nvPr>
+            <p:ph type="sldImg"/>
+          </p:nvPr>
+        </p:nvSpPr>
+        <p:spPr/>
+      </p:sp>
+      <p:sp>
+        <p:nvSpPr>
+          <p:cNvPr id="3" name="Notes Placeholder 2">
+            <a:extLst>
+              <a:ext uri="{FF2B5EF4-FFF2-40B4-BE49-F238E27FC236}">
+                <a16:creationId xmlns:a16="http://schemas.microsoft.com/office/drawing/2014/main" id="{2002C3B7-CA77-DBDA-1760-B053A560197F}"/>
+              </a:ext>
+            </a:extLst>
+          </p:cNvPr>
+          <p:cNvSpPr>
+            <a:spLocks noGrp="1"/>
+          </p:cNvSpPr>
+          <p:nvPr>
+            <p:ph type="body" idx="1"/>
+          </p:nvPr>
+        </p:nvSpPr>
+        <p:spPr/>
+        <p:txBody>
+          <a:bodyPr/>
+          <a:lstStyle/>
+          <a:p>
+            <a:pPr marL="0" marR="0" lvl="0" indent="0" algn="l" defTabSz="914400" rtl="0" eaLnBrk="1" fontAlgn="auto" latinLnBrk="0" hangingPunct="1">
+              <a:lnSpc>
+                <a:spcPct val="100000"/>
+              </a:lnSpc>
+              <a:spcBef>
+                <a:spcPts val="0"/>
+              </a:spcBef>
+              <a:spcAft>
+                <a:spcPts val="0"/>
+              </a:spcAft>
+              <a:buClrTx/>
+              <a:buSzTx/>
+              <a:buFontTx/>
+              <a:buNone/>
+              <a:tabLst/>
+              <a:defRPr/>
+            </a:pPr>
+            <a:r>
+              <a:rPr lang="en-US" dirty="0"/>
+              <a:t>Pancreatic Ductal Adenocarcinoma is the most common subtype of pancreatic cancer, constituting about 90% of all pancreatic cancer. PDAC is the third leading cause of cancer-related deaths in the U.S., with a 5-year survival rate of only 13.3%. It is also known to have extremely poor prognosis, with nearly 90% of tumors already metastasized at diagnosis. </a:t>
+            </a:r>
+          </a:p>
+          <a:p>
+            <a:pPr marL="0" marR="0" lvl="0" indent="0" algn="l" defTabSz="914400" rtl="0" eaLnBrk="1" fontAlgn="auto" latinLnBrk="0" hangingPunct="1">
+              <a:lnSpc>
+                <a:spcPct val="100000"/>
+              </a:lnSpc>
+              <a:spcBef>
+                <a:spcPts val="0"/>
+              </a:spcBef>
+              <a:spcAft>
+                <a:spcPts val="0"/>
+              </a:spcAft>
+              <a:buClrTx/>
+              <a:buSzTx/>
+              <a:buFontTx/>
+              <a:buNone/>
+              <a:tabLst/>
+              <a:defRPr/>
+            </a:pPr>
+            <a:endParaRPr lang="en-US" dirty="0"/>
+          </a:p>
+          <a:p>
+            <a:pPr marL="0" marR="0" lvl="0" indent="0" algn="l" defTabSz="914400" rtl="0" eaLnBrk="1" fontAlgn="auto" latinLnBrk="0" hangingPunct="1">
+              <a:lnSpc>
+                <a:spcPct val="100000"/>
+              </a:lnSpc>
+              <a:spcBef>
+                <a:spcPts val="0"/>
+              </a:spcBef>
+              <a:spcAft>
+                <a:spcPts val="0"/>
+              </a:spcAft>
+              <a:buClrTx/>
+              <a:buSzTx/>
+              <a:buFontTx/>
+              <a:buNone/>
+              <a:tabLst/>
+              <a:defRPr/>
+            </a:pPr>
+            <a:endParaRPr lang="en-US" dirty="0"/>
+          </a:p>
+          <a:p>
+            <a:pPr marL="0" marR="0" lvl="0" indent="0" algn="l" defTabSz="914400" rtl="0" eaLnBrk="1" fontAlgn="auto" latinLnBrk="0" hangingPunct="1">
+              <a:lnSpc>
+                <a:spcPct val="100000"/>
+              </a:lnSpc>
+              <a:spcBef>
+                <a:spcPts val="0"/>
+              </a:spcBef>
+              <a:spcAft>
+                <a:spcPts val="0"/>
+              </a:spcAft>
+              <a:buClrTx/>
+              <a:buSzTx/>
+              <a:buFontTx/>
+              <a:buNone/>
+              <a:tabLst/>
+              <a:defRPr/>
+            </a:pPr>
+            <a:endParaRPr lang="en-US" dirty="0"/>
+          </a:p>
+          <a:p>
+            <a:pPr marL="0" marR="0" lvl="0" indent="0" algn="l" defTabSz="914400" rtl="0" eaLnBrk="1" fontAlgn="auto" latinLnBrk="0" hangingPunct="1">
+              <a:lnSpc>
+                <a:spcPct val="100000"/>
+              </a:lnSpc>
+              <a:spcBef>
+                <a:spcPts val="0"/>
+              </a:spcBef>
+              <a:spcAft>
+                <a:spcPts val="0"/>
+              </a:spcAft>
+              <a:buClrTx/>
+              <a:buSzTx/>
+              <a:buFontTx/>
+              <a:buNone/>
+              <a:tabLst/>
+              <a:defRPr/>
+            </a:pPr>
+            <a:endParaRPr lang="en-US" dirty="0"/>
+          </a:p>
+          <a:p>
+            <a:pPr marL="0" marR="0" lvl="0" indent="0" algn="l" defTabSz="914400" rtl="0" eaLnBrk="1" fontAlgn="auto" latinLnBrk="0" hangingPunct="1">
+              <a:lnSpc>
+                <a:spcPct val="100000"/>
+              </a:lnSpc>
+              <a:spcBef>
+                <a:spcPts val="0"/>
+              </a:spcBef>
+              <a:spcAft>
+                <a:spcPts val="0"/>
+              </a:spcAft>
+              <a:buClrTx/>
+              <a:buSzTx/>
+              <a:buFontTx/>
+              <a:buNone/>
+              <a:tabLst/>
+              <a:defRPr/>
+            </a:pPr>
+            <a:r>
+              <a:rPr lang="en-US" dirty="0"/>
+              <a:t>PDAC begins in the epithelial cells lining the pancreatic ducts, which are normally responsible for regulating secretion of digestive enzymes into the small intestine. In PDAC, these cells acquire mutations that cause them to proliferate uncontrollably and eventually rupture the ductal membrane. After spreading into the stroma, cancer-associated fibroblasts develop dense networks of collogen fibers, known as desmoplasia, around the previous pancreatic ducts. This creates almost like a shield around the tumor, protecting it from immune attack and drug penetration. </a:t>
+            </a:r>
+          </a:p>
+          <a:p>
+            <a:pPr marL="0" marR="0" lvl="0" indent="0" algn="l" defTabSz="914400" rtl="0" eaLnBrk="1" fontAlgn="auto" latinLnBrk="0" hangingPunct="1">
+              <a:lnSpc>
+                <a:spcPct val="100000"/>
+              </a:lnSpc>
+              <a:spcBef>
+                <a:spcPts val="0"/>
+              </a:spcBef>
+              <a:spcAft>
+                <a:spcPts val="0"/>
+              </a:spcAft>
+              <a:buClrTx/>
+              <a:buSzTx/>
+              <a:buFontTx/>
+              <a:buNone/>
+              <a:tabLst/>
+              <a:defRPr/>
+            </a:pPr>
+            <a:endParaRPr lang="en-US" dirty="0"/>
+          </a:p>
+          <a:p>
+            <a:pPr marL="0" marR="0" lvl="0" indent="0" algn="l" defTabSz="914400" rtl="0" eaLnBrk="1" fontAlgn="auto" latinLnBrk="0" hangingPunct="1">
+              <a:lnSpc>
+                <a:spcPct val="100000"/>
+              </a:lnSpc>
+              <a:spcBef>
+                <a:spcPts val="0"/>
+              </a:spcBef>
+              <a:spcAft>
+                <a:spcPts val="0"/>
+              </a:spcAft>
+              <a:buClrTx/>
+              <a:buSzTx/>
+              <a:buFontTx/>
+              <a:buNone/>
+              <a:tabLst/>
+              <a:defRPr/>
+            </a:pPr>
+            <a:r>
+              <a:rPr lang="en-US" dirty="0"/>
+              <a:t>Pancreatic ductal adenocarcinoma is the most common subtype of pancreatic cancer, with a 5 year survival rate of only 13%. The low survival rate is thought to be due to multiple challenges to treatment such as the difficulty of detecting PDAC before it has metastasized. (add graphic) A hallmark of PDAC is what’s called a “desmoplastic” tumor microenvironment. Compared to healthy tissue on the left, PDAC on the right has masses of cell growth in places that used to be healthy ducts, and is infiltrated by a greater diversity of immune and stromal cells while being crisscrossed and encapsulated in this network of collagen fibers, which are deposited by cancer-associated fibroblasts. </a:t>
+            </a:r>
+            <a:r>
+              <a:rPr lang="en-US" sz="1200" dirty="0"/>
+              <a:t>The dense fibrotic network of collagen is referred to as desmoplasia and is seen in certain types of tumors.</a:t>
+            </a:r>
+            <a:endParaRPr lang="en-US" dirty="0"/>
+          </a:p>
+          <a:p>
+            <a:pPr marL="0" marR="0" lvl="0" indent="0" algn="l" defTabSz="914400" rtl="0" eaLnBrk="1" fontAlgn="auto" latinLnBrk="0" hangingPunct="1">
+              <a:lnSpc>
+                <a:spcPct val="100000"/>
+              </a:lnSpc>
+              <a:spcBef>
+                <a:spcPts val="0"/>
+              </a:spcBef>
+              <a:spcAft>
+                <a:spcPts val="0"/>
+              </a:spcAft>
+              <a:buClrTx/>
+              <a:buSzTx/>
+              <a:buFontTx/>
+              <a:buNone/>
+              <a:tabLst/>
+              <a:defRPr/>
+            </a:pPr>
+            <a:endParaRPr lang="en-US" dirty="0"/>
+          </a:p>
+          <a:p>
+            <a:pPr marL="0" marR="0" lvl="0" indent="0" algn="l" defTabSz="914400" rtl="0" eaLnBrk="1" fontAlgn="auto" latinLnBrk="0" hangingPunct="1">
+              <a:lnSpc>
+                <a:spcPct val="100000"/>
+              </a:lnSpc>
+              <a:spcBef>
+                <a:spcPts val="0"/>
+              </a:spcBef>
+              <a:spcAft>
+                <a:spcPts val="0"/>
+              </a:spcAft>
+              <a:buClrTx/>
+              <a:buSzTx/>
+              <a:buFontTx/>
+              <a:buNone/>
+              <a:tabLst/>
+              <a:defRPr/>
+            </a:pPr>
+            <a:r>
+              <a:rPr lang="en-US" dirty="0"/>
+              <a:t>Those immune cells that are found in this microenvironment are often suppressive such as T regulatory cells and suppressive macrophages. Some of the immune cells are “residents” that were probably there in the healthy tissue, but others are recruited from the periphery (</a:t>
+            </a:r>
+            <a:r>
+              <a:rPr lang="en-US" dirty="0" err="1"/>
+              <a:t>BM+blood</a:t>
+            </a:r>
+            <a:r>
+              <a:rPr lang="en-US" dirty="0"/>
+              <a:t>)</a:t>
+            </a:r>
+          </a:p>
+          <a:p>
+            <a:endParaRPr lang="en-US" dirty="0"/>
+          </a:p>
+        </p:txBody>
+      </p:sp>
+      <p:sp>
+        <p:nvSpPr>
+          <p:cNvPr id="4" name="Slide Number Placeholder 3">
+            <a:extLst>
+              <a:ext uri="{FF2B5EF4-FFF2-40B4-BE49-F238E27FC236}">
+                <a16:creationId xmlns:a16="http://schemas.microsoft.com/office/drawing/2014/main" id="{5FED305B-E9E4-7F87-830E-82E9C8FE696E}"/>
+              </a:ext>
+            </a:extLst>
+          </p:cNvPr>
+          <p:cNvSpPr>
+            <a:spLocks noGrp="1"/>
+          </p:cNvSpPr>
+          <p:nvPr>
+            <p:ph type="sldNum" sz="quarter" idx="5"/>
+          </p:nvPr>
+        </p:nvSpPr>
+        <p:spPr/>
+        <p:txBody>
+          <a:bodyPr/>
+          <a:lstStyle/>
+          <a:p>
+            <a:fld id="{B314B106-72D9-394B-AE7F-13630EA62899}" type="slidenum">
+              <a:rPr lang="en-US" smtClean="0"/>
+              <a:t>5</a:t>
+            </a:fld>
+            <a:endParaRPr lang="en-US"/>
+          </a:p>
+        </p:txBody>
+      </p:sp>
+    </p:spTree>
+    <p:extLst>
+      <p:ext uri="{BB962C8B-B14F-4D97-AF65-F5344CB8AC3E}">
+        <p14:creationId xmlns:p14="http://schemas.microsoft.com/office/powerpoint/2010/main" val="3010061097"/>
+      </p:ext>
+    </p:extLst>
+  </p:cSld>
+  <p:clrMapOvr>
+    <a:masterClrMapping/>
+  </p:clrMapOvr>
+</p:notes>
+</file>
+
+<file path=ppt/notesSlides/notesSlide6.xml><?xml version="1.0" encoding="utf-8"?>
+<p:notes xmlns:a="http://schemas.openxmlformats.org/drawingml/2006/main" xmlns:r="http://schemas.openxmlformats.org/officeDocument/2006/relationships" xmlns:p="http://schemas.openxmlformats.org/presentationml/2006/main">
+  <p:cSld>
+    <p:spTree>
+      <p:nvGrpSpPr>
+        <p:cNvPr id="1" name="">
+          <a:extLst>
+            <a:ext uri="{FF2B5EF4-FFF2-40B4-BE49-F238E27FC236}">
+              <a16:creationId xmlns:a16="http://schemas.microsoft.com/office/drawing/2014/main" id="{59C71709-5504-9512-F144-8BB0FA7DEC38}"/>
+            </a:ext>
+          </a:extLst>
+        </p:cNvPr>
+        <p:cNvGrpSpPr/>
+        <p:nvPr/>
+      </p:nvGrpSpPr>
+      <p:grpSpPr>
+        <a:xfrm>
+          <a:off x="0" y="0"/>
+          <a:ext cx="0" cy="0"/>
+          <a:chOff x="0" y="0"/>
+          <a:chExt cx="0" cy="0"/>
+        </a:xfrm>
+      </p:grpSpPr>
+      <p:sp>
+        <p:nvSpPr>
+          <p:cNvPr id="2" name="Slide Image Placeholder 1">
+            <a:extLst>
+              <a:ext uri="{FF2B5EF4-FFF2-40B4-BE49-F238E27FC236}">
+                <a16:creationId xmlns:a16="http://schemas.microsoft.com/office/drawing/2014/main" id="{B1F6ECED-793E-1853-3637-313BE91F8013}"/>
+              </a:ext>
+            </a:extLst>
+          </p:cNvPr>
+          <p:cNvSpPr>
+            <a:spLocks noGrp="1" noRot="1" noChangeAspect="1"/>
+          </p:cNvSpPr>
+          <p:nvPr>
+            <p:ph type="sldImg"/>
+          </p:nvPr>
+        </p:nvSpPr>
+        <p:spPr/>
+      </p:sp>
+      <p:sp>
+        <p:nvSpPr>
+          <p:cNvPr id="3" name="Notes Placeholder 2">
+            <a:extLst>
+              <a:ext uri="{FF2B5EF4-FFF2-40B4-BE49-F238E27FC236}">
+                <a16:creationId xmlns:a16="http://schemas.microsoft.com/office/drawing/2014/main" id="{589209C2-300A-C0DC-D11A-B1374B1E530D}"/>
+              </a:ext>
+            </a:extLst>
+          </p:cNvPr>
+          <p:cNvSpPr>
+            <a:spLocks noGrp="1"/>
+          </p:cNvSpPr>
+          <p:nvPr>
+            <p:ph type="body" idx="1"/>
+          </p:nvPr>
+        </p:nvSpPr>
+        <p:spPr/>
+        <p:txBody>
+          <a:bodyPr/>
+          <a:lstStyle/>
+          <a:p>
+            <a:endParaRPr lang="en-US" dirty="0"/>
+          </a:p>
+        </p:txBody>
+      </p:sp>
+      <p:sp>
+        <p:nvSpPr>
+          <p:cNvPr id="4" name="Slide Number Placeholder 3">
+            <a:extLst>
+              <a:ext uri="{FF2B5EF4-FFF2-40B4-BE49-F238E27FC236}">
+                <a16:creationId xmlns:a16="http://schemas.microsoft.com/office/drawing/2014/main" id="{01A49AEE-9D1A-E306-8A9D-07D1498F8051}"/>
+              </a:ext>
+            </a:extLst>
+          </p:cNvPr>
+          <p:cNvSpPr>
+            <a:spLocks noGrp="1"/>
+          </p:cNvSpPr>
+          <p:nvPr>
+            <p:ph type="sldNum" sz="quarter" idx="5"/>
+          </p:nvPr>
+        </p:nvSpPr>
+        <p:spPr/>
+        <p:txBody>
+          <a:bodyPr/>
+          <a:lstStyle/>
+          <a:p>
+            <a:fld id="{B314B106-72D9-394B-AE7F-13630EA62899}" type="slidenum">
+              <a:rPr lang="en-US" smtClean="0"/>
+              <a:t>6</a:t>
+            </a:fld>
+            <a:endParaRPr lang="en-US"/>
+          </a:p>
+        </p:txBody>
+      </p:sp>
+    </p:spTree>
+    <p:extLst>
+      <p:ext uri="{BB962C8B-B14F-4D97-AF65-F5344CB8AC3E}">
+        <p14:creationId xmlns:p14="http://schemas.microsoft.com/office/powerpoint/2010/main" val="1519764364"/>
+      </p:ext>
+    </p:extLst>
+  </p:cSld>
+  <p:clrMapOvr>
+    <a:masterClrMapping/>
+  </p:clrMapOvr>
+</p:notes>
+</file>
+
+<file path=ppt/notesSlides/notesSlide7.xml><?xml version="1.0" encoding="utf-8"?>
+<p:notes xmlns:a="http://schemas.openxmlformats.org/drawingml/2006/main" xmlns:r="http://schemas.openxmlformats.org/officeDocument/2006/relationships" xmlns:p="http://schemas.openxmlformats.org/presentationml/2006/main">
+  <p:cSld>
+    <p:spTree>
+      <p:nvGrpSpPr>
+        <p:cNvPr id="1" name="">
+          <a:extLst>
+            <a:ext uri="{FF2B5EF4-FFF2-40B4-BE49-F238E27FC236}">
+              <a16:creationId xmlns:a16="http://schemas.microsoft.com/office/drawing/2014/main" id="{042B31A3-D05E-857D-AD7F-2ACE1DD0D113}"/>
+            </a:ext>
+          </a:extLst>
+        </p:cNvPr>
+        <p:cNvGrpSpPr/>
+        <p:nvPr/>
+      </p:nvGrpSpPr>
+      <p:grpSpPr>
+        <a:xfrm>
+          <a:off x="0" y="0"/>
+          <a:ext cx="0" cy="0"/>
+          <a:chOff x="0" y="0"/>
+          <a:chExt cx="0" cy="0"/>
+        </a:xfrm>
+      </p:grpSpPr>
+      <p:sp>
+        <p:nvSpPr>
+          <p:cNvPr id="2" name="Slide Image Placeholder 1">
+            <a:extLst>
+              <a:ext uri="{FF2B5EF4-FFF2-40B4-BE49-F238E27FC236}">
+                <a16:creationId xmlns:a16="http://schemas.microsoft.com/office/drawing/2014/main" id="{762593F4-4088-8DFD-66A3-4E0CE44A6984}"/>
+              </a:ext>
+            </a:extLst>
+          </p:cNvPr>
+          <p:cNvSpPr>
+            <a:spLocks noGrp="1" noRot="1" noChangeAspect="1"/>
+          </p:cNvSpPr>
+          <p:nvPr>
+            <p:ph type="sldImg"/>
+          </p:nvPr>
+        </p:nvSpPr>
+        <p:spPr/>
+      </p:sp>
+      <p:sp>
+        <p:nvSpPr>
+          <p:cNvPr id="3" name="Notes Placeholder 2">
+            <a:extLst>
+              <a:ext uri="{FF2B5EF4-FFF2-40B4-BE49-F238E27FC236}">
+                <a16:creationId xmlns:a16="http://schemas.microsoft.com/office/drawing/2014/main" id="{908F8F54-8A41-56B8-19B3-6FCB419EFA8E}"/>
+              </a:ext>
+            </a:extLst>
+          </p:cNvPr>
+          <p:cNvSpPr>
+            <a:spLocks noGrp="1"/>
+          </p:cNvSpPr>
+          <p:nvPr>
+            <p:ph type="body" idx="1"/>
+          </p:nvPr>
+        </p:nvSpPr>
+        <p:spPr/>
+        <p:txBody>
+          <a:bodyPr/>
+          <a:lstStyle/>
+          <a:p>
+            <a:endParaRPr lang="en-US" dirty="0"/>
+          </a:p>
+        </p:txBody>
+      </p:sp>
+      <p:sp>
+        <p:nvSpPr>
+          <p:cNvPr id="4" name="Slide Number Placeholder 3">
+            <a:extLst>
+              <a:ext uri="{FF2B5EF4-FFF2-40B4-BE49-F238E27FC236}">
+                <a16:creationId xmlns:a16="http://schemas.microsoft.com/office/drawing/2014/main" id="{79890822-F19A-E324-39EC-0736D0BBBBBE}"/>
+              </a:ext>
+            </a:extLst>
+          </p:cNvPr>
+          <p:cNvSpPr>
+            <a:spLocks noGrp="1"/>
+          </p:cNvSpPr>
+          <p:nvPr>
+            <p:ph type="sldNum" sz="quarter" idx="5"/>
+          </p:nvPr>
+        </p:nvSpPr>
+        <p:spPr/>
+        <p:txBody>
+          <a:bodyPr/>
+          <a:lstStyle/>
+          <a:p>
+            <a:fld id="{B314B106-72D9-394B-AE7F-13630EA62899}" type="slidenum">
+              <a:rPr lang="en-US" smtClean="0"/>
+              <a:t>7</a:t>
+            </a:fld>
+            <a:endParaRPr lang="en-US"/>
+          </a:p>
+        </p:txBody>
+      </p:sp>
+    </p:spTree>
+    <p:extLst>
+      <p:ext uri="{BB962C8B-B14F-4D97-AF65-F5344CB8AC3E}">
+        <p14:creationId xmlns:p14="http://schemas.microsoft.com/office/powerpoint/2010/main" val="4114091203"/>
+      </p:ext>
+    </p:extLst>
+  </p:cSld>
+  <p:clrMapOvr>
+    <a:masterClrMapping/>
+  </p:clrMapOvr>
+</p:notes>
+</file>
+
+<file path=ppt/notesSlides/notesSlide8.xml><?xml version="1.0" encoding="utf-8"?>
+<p:notes xmlns:a="http://schemas.openxmlformats.org/drawingml/2006/main" xmlns:r="http://schemas.openxmlformats.org/officeDocument/2006/relationships" xmlns:p="http://schemas.openxmlformats.org/presentationml/2006/main">
+  <p:cSld>
+    <p:spTree>
+      <p:nvGrpSpPr>
+        <p:cNvPr id="1" name="">
+          <a:extLst>
+            <a:ext uri="{FF2B5EF4-FFF2-40B4-BE49-F238E27FC236}">
+              <a16:creationId xmlns:a16="http://schemas.microsoft.com/office/drawing/2014/main" id="{BCD59404-1B99-A960-8E16-A2AC01F74ECB}"/>
+            </a:ext>
+          </a:extLst>
+        </p:cNvPr>
+        <p:cNvGrpSpPr/>
+        <p:nvPr/>
+      </p:nvGrpSpPr>
+      <p:grpSpPr>
+        <a:xfrm>
+          <a:off x="0" y="0"/>
+          <a:ext cx="0" cy="0"/>
+          <a:chOff x="0" y="0"/>
+          <a:chExt cx="0" cy="0"/>
+        </a:xfrm>
+      </p:grpSpPr>
+      <p:sp>
+        <p:nvSpPr>
+          <p:cNvPr id="2" name="Slide Image Placeholder 1">
+            <a:extLst>
+              <a:ext uri="{FF2B5EF4-FFF2-40B4-BE49-F238E27FC236}">
+                <a16:creationId xmlns:a16="http://schemas.microsoft.com/office/drawing/2014/main" id="{7F42209C-4D7D-6791-34F7-75AC6BD0BC80}"/>
+              </a:ext>
+            </a:extLst>
+          </p:cNvPr>
+          <p:cNvSpPr>
+            <a:spLocks noGrp="1" noRot="1" noChangeAspect="1"/>
+          </p:cNvSpPr>
+          <p:nvPr>
+            <p:ph type="sldImg"/>
+          </p:nvPr>
+        </p:nvSpPr>
+        <p:spPr/>
+      </p:sp>
+      <p:sp>
+        <p:nvSpPr>
+          <p:cNvPr id="3" name="Notes Placeholder 2">
+            <a:extLst>
+              <a:ext uri="{FF2B5EF4-FFF2-40B4-BE49-F238E27FC236}">
+                <a16:creationId xmlns:a16="http://schemas.microsoft.com/office/drawing/2014/main" id="{4C4E30B8-F743-33AD-F835-20924D0C3FD3}"/>
+              </a:ext>
+            </a:extLst>
+          </p:cNvPr>
+          <p:cNvSpPr>
+            <a:spLocks noGrp="1"/>
+          </p:cNvSpPr>
+          <p:nvPr>
+            <p:ph type="body" idx="1"/>
+          </p:nvPr>
+        </p:nvSpPr>
+        <p:spPr/>
+        <p:txBody>
+          <a:bodyPr/>
+          <a:lstStyle/>
+          <a:p>
+            <a:pPr marL="0" marR="0" lvl="0" indent="0" algn="l" defTabSz="914400" rtl="0" eaLnBrk="1" fontAlgn="auto" latinLnBrk="0" hangingPunct="1">
+              <a:lnSpc>
+                <a:spcPct val="100000"/>
+              </a:lnSpc>
+              <a:spcBef>
+                <a:spcPts val="0"/>
+              </a:spcBef>
+              <a:spcAft>
+                <a:spcPts val="0"/>
+              </a:spcAft>
+              <a:buClrTx/>
+              <a:buSzTx/>
+              <a:buFontTx/>
+              <a:buNone/>
+              <a:tabLst/>
+              <a:defRPr/>
+            </a:pPr>
+            <a:r>
+              <a:rPr lang="en-US" dirty="0"/>
+              <a:t>Pancreatic Ductal Adenocarcinoma is the most common subtype of pancreatic cancer, constituting about 90% of all pancreatic cancer. PDAC is the third leading cause of cancer-related deaths in the U.S., with a 5-year survival rate of only 13.3%. It is also known to have extremely poor prognosis, with nearly 90% of tumors already metastasized at diagnosis. </a:t>
+            </a:r>
+          </a:p>
+          <a:p>
+            <a:pPr marL="0" marR="0" lvl="0" indent="0" algn="l" defTabSz="914400" rtl="0" eaLnBrk="1" fontAlgn="auto" latinLnBrk="0" hangingPunct="1">
+              <a:lnSpc>
+                <a:spcPct val="100000"/>
+              </a:lnSpc>
+              <a:spcBef>
+                <a:spcPts val="0"/>
+              </a:spcBef>
+              <a:spcAft>
+                <a:spcPts val="0"/>
+              </a:spcAft>
+              <a:buClrTx/>
+              <a:buSzTx/>
+              <a:buFontTx/>
+              <a:buNone/>
+              <a:tabLst/>
+              <a:defRPr/>
+            </a:pPr>
+            <a:endParaRPr lang="en-US" dirty="0"/>
+          </a:p>
+          <a:p>
+            <a:pPr marL="0" marR="0" lvl="0" indent="0" algn="l" defTabSz="914400" rtl="0" eaLnBrk="1" fontAlgn="auto" latinLnBrk="0" hangingPunct="1">
+              <a:lnSpc>
+                <a:spcPct val="100000"/>
+              </a:lnSpc>
+              <a:spcBef>
+                <a:spcPts val="0"/>
+              </a:spcBef>
+              <a:spcAft>
+                <a:spcPts val="0"/>
+              </a:spcAft>
+              <a:buClrTx/>
+              <a:buSzTx/>
+              <a:buFontTx/>
+              <a:buNone/>
+              <a:tabLst/>
+              <a:defRPr/>
+            </a:pPr>
+            <a:endParaRPr lang="en-US" dirty="0"/>
+          </a:p>
+          <a:p>
+            <a:pPr marL="0" marR="0" lvl="0" indent="0" algn="l" defTabSz="914400" rtl="0" eaLnBrk="1" fontAlgn="auto" latinLnBrk="0" hangingPunct="1">
+              <a:lnSpc>
+                <a:spcPct val="100000"/>
+              </a:lnSpc>
+              <a:spcBef>
+                <a:spcPts val="0"/>
+              </a:spcBef>
+              <a:spcAft>
+                <a:spcPts val="0"/>
+              </a:spcAft>
+              <a:buClrTx/>
+              <a:buSzTx/>
+              <a:buFontTx/>
+              <a:buNone/>
+              <a:tabLst/>
+              <a:defRPr/>
+            </a:pPr>
+            <a:endParaRPr lang="en-US" dirty="0"/>
+          </a:p>
+          <a:p>
+            <a:pPr marL="0" marR="0" lvl="0" indent="0" algn="l" defTabSz="914400" rtl="0" eaLnBrk="1" fontAlgn="auto" latinLnBrk="0" hangingPunct="1">
+              <a:lnSpc>
+                <a:spcPct val="100000"/>
+              </a:lnSpc>
+              <a:spcBef>
+                <a:spcPts val="0"/>
+              </a:spcBef>
+              <a:spcAft>
+                <a:spcPts val="0"/>
+              </a:spcAft>
+              <a:buClrTx/>
+              <a:buSzTx/>
+              <a:buFontTx/>
+              <a:buNone/>
+              <a:tabLst/>
+              <a:defRPr/>
+            </a:pPr>
+            <a:endParaRPr lang="en-US" dirty="0"/>
+          </a:p>
+          <a:p>
+            <a:pPr marL="0" marR="0" lvl="0" indent="0" algn="l" defTabSz="914400" rtl="0" eaLnBrk="1" fontAlgn="auto" latinLnBrk="0" hangingPunct="1">
+              <a:lnSpc>
+                <a:spcPct val="100000"/>
+              </a:lnSpc>
+              <a:spcBef>
+                <a:spcPts val="0"/>
+              </a:spcBef>
+              <a:spcAft>
+                <a:spcPts val="0"/>
+              </a:spcAft>
+              <a:buClrTx/>
+              <a:buSzTx/>
+              <a:buFontTx/>
+              <a:buNone/>
+              <a:tabLst/>
+              <a:defRPr/>
+            </a:pPr>
+            <a:r>
+              <a:rPr lang="en-US" dirty="0"/>
+              <a:t>PDAC begins in the epithelial cells lining the pancreatic ducts, which are normally responsible for regulating secretion of digestive enzymes into the small intestine. In PDAC, these cells acquire mutations that cause them to proliferate uncontrollably and eventually rupture the ductal membrane. After spreading into the stroma, cancer-associated fibroblasts develop dense networks of collogen fibers, known as desmoplasia, around the previous pancreatic ducts. This creates almost like a shield around the tumor, protecting it from immune attack and drug penetration. </a:t>
+            </a:r>
+          </a:p>
+          <a:p>
+            <a:pPr marL="0" marR="0" lvl="0" indent="0" algn="l" defTabSz="914400" rtl="0" eaLnBrk="1" fontAlgn="auto" latinLnBrk="0" hangingPunct="1">
+              <a:lnSpc>
+                <a:spcPct val="100000"/>
+              </a:lnSpc>
+              <a:spcBef>
+                <a:spcPts val="0"/>
+              </a:spcBef>
+              <a:spcAft>
+                <a:spcPts val="0"/>
+              </a:spcAft>
+              <a:buClrTx/>
+              <a:buSzTx/>
+              <a:buFontTx/>
+              <a:buNone/>
+              <a:tabLst/>
+              <a:defRPr/>
+            </a:pPr>
+            <a:endParaRPr lang="en-US" dirty="0"/>
+          </a:p>
+          <a:p>
+            <a:pPr marL="0" marR="0" lvl="0" indent="0" algn="l" defTabSz="914400" rtl="0" eaLnBrk="1" fontAlgn="auto" latinLnBrk="0" hangingPunct="1">
+              <a:lnSpc>
+                <a:spcPct val="100000"/>
+              </a:lnSpc>
+              <a:spcBef>
+                <a:spcPts val="0"/>
+              </a:spcBef>
+              <a:spcAft>
+                <a:spcPts val="0"/>
+              </a:spcAft>
+              <a:buClrTx/>
+              <a:buSzTx/>
+              <a:buFontTx/>
+              <a:buNone/>
+              <a:tabLst/>
+              <a:defRPr/>
+            </a:pPr>
+            <a:r>
+              <a:rPr lang="en-US" dirty="0"/>
+              <a:t>Pancreatic ductal adenocarcinoma is the most common subtype of pancreatic cancer, with a 5 year survival rate of only 13%. The low survival rate is thought to be due to multiple challenges to treatment such as the difficulty of detecting PDAC before it has metastasized. (add graphic) A hallmark of PDAC is what’s called a “desmoplastic” tumor microenvironment. Compared to healthy tissue on the left, PDAC on the right has masses of cell growth in places that used to be healthy ducts, and is infiltrated by a greater diversity of immune and stromal cells while being crisscrossed and encapsulated in this network of collagen fibers, which are deposited by cancer-associated fibroblasts. </a:t>
+            </a:r>
+            <a:r>
+              <a:rPr lang="en-US" sz="1200" dirty="0"/>
+              <a:t>The dense fibrotic network of collagen is referred to as desmoplasia and is seen in certain types of tumors.</a:t>
+            </a:r>
+            <a:endParaRPr lang="en-US" dirty="0"/>
+          </a:p>
+          <a:p>
+            <a:pPr marL="0" marR="0" lvl="0" indent="0" algn="l" defTabSz="914400" rtl="0" eaLnBrk="1" fontAlgn="auto" latinLnBrk="0" hangingPunct="1">
+              <a:lnSpc>
+                <a:spcPct val="100000"/>
+              </a:lnSpc>
+              <a:spcBef>
+                <a:spcPts val="0"/>
+              </a:spcBef>
+              <a:spcAft>
+                <a:spcPts val="0"/>
+              </a:spcAft>
+              <a:buClrTx/>
+              <a:buSzTx/>
+              <a:buFontTx/>
+              <a:buNone/>
+              <a:tabLst/>
+              <a:defRPr/>
+            </a:pPr>
+            <a:endParaRPr lang="en-US" dirty="0"/>
+          </a:p>
+          <a:p>
+            <a:pPr marL="0" marR="0" lvl="0" indent="0" algn="l" defTabSz="914400" rtl="0" eaLnBrk="1" fontAlgn="auto" latinLnBrk="0" hangingPunct="1">
+              <a:lnSpc>
+                <a:spcPct val="100000"/>
+              </a:lnSpc>
+              <a:spcBef>
+                <a:spcPts val="0"/>
+              </a:spcBef>
+              <a:spcAft>
+                <a:spcPts val="0"/>
+              </a:spcAft>
+              <a:buClrTx/>
+              <a:buSzTx/>
+              <a:buFontTx/>
+              <a:buNone/>
+              <a:tabLst/>
+              <a:defRPr/>
+            </a:pPr>
+            <a:r>
+              <a:rPr lang="en-US" dirty="0"/>
+              <a:t>Those immune cells that are found in this microenvironment are often suppressive such as T regulatory cells and suppressive macrophages. Some of the immune cells are “residents” that were probably there in the healthy tissue, but others are recruited from the periphery (</a:t>
+            </a:r>
+            <a:r>
+              <a:rPr lang="en-US" dirty="0" err="1"/>
+              <a:t>BM+blood</a:t>
+            </a:r>
+            <a:r>
+              <a:rPr lang="en-US" dirty="0"/>
+              <a:t>)</a:t>
+            </a:r>
+          </a:p>
+          <a:p>
+            <a:endParaRPr lang="en-US" dirty="0"/>
+          </a:p>
+        </p:txBody>
+      </p:sp>
+      <p:sp>
+        <p:nvSpPr>
+          <p:cNvPr id="4" name="Slide Number Placeholder 3">
+            <a:extLst>
+              <a:ext uri="{FF2B5EF4-FFF2-40B4-BE49-F238E27FC236}">
+                <a16:creationId xmlns:a16="http://schemas.microsoft.com/office/drawing/2014/main" id="{7BBB98FC-CFA5-267A-ADC6-F5ED56546EA1}"/>
+              </a:ext>
+            </a:extLst>
+          </p:cNvPr>
+          <p:cNvSpPr>
+            <a:spLocks noGrp="1"/>
+          </p:cNvSpPr>
+          <p:nvPr>
+            <p:ph type="sldNum" sz="quarter" idx="5"/>
+          </p:nvPr>
+        </p:nvSpPr>
+        <p:spPr/>
+        <p:txBody>
+          <a:bodyPr/>
+          <a:lstStyle/>
+          <a:p>
+            <a:fld id="{B314B106-72D9-394B-AE7F-13630EA62899}" type="slidenum">
+              <a:rPr lang="en-US" smtClean="0"/>
+              <a:t>8</a:t>
+            </a:fld>
+            <a:endParaRPr lang="en-US"/>
+          </a:p>
+        </p:txBody>
+      </p:sp>
+    </p:spTree>
+    <p:extLst>
+      <p:ext uri="{BB962C8B-B14F-4D97-AF65-F5344CB8AC3E}">
+        <p14:creationId xmlns:p14="http://schemas.microsoft.com/office/powerpoint/2010/main" val="4026622934"/>
       </p:ext>
     </p:extLst>
   </p:cSld>
@@ -1609,7 +2829,7 @@
             <a:fld id="{2B799761-2EBC-ED48-8421-93C3DA969FB7}" type="datetimeFigureOut">
               <a:rPr lang="en-US" smtClean="0"/>
               <a:pPr/>
-              <a:t>9/5/2025</a:t>
+              <a:t>9/19/2025</a:t>
             </a:fld>
             <a:endParaRPr lang="en-US"/>
           </a:p>
@@ -1840,7 +3060,7 @@
             <a:fld id="{60F76AEE-5F7C-0C4E-AB7D-BADB32FF08A3}" type="datetimeFigureOut">
               <a:rPr lang="en-US" smtClean="0"/>
               <a:pPr/>
-              <a:t>9/5/2025</a:t>
+              <a:t>9/19/2025</a:t>
             </a:fld>
             <a:endParaRPr lang="en-US"/>
           </a:p>
@@ -2882,7 +4102,7 @@
         </p:nvSpPr>
         <p:spPr>
           <a:xfrm>
-            <a:off x="603662" y="849975"/>
+            <a:off x="591136" y="712188"/>
             <a:ext cx="7658596" cy="2203244"/>
           </a:xfrm>
         </p:spPr>
@@ -2923,7 +4143,7 @@
         </p:nvSpPr>
         <p:spPr>
           <a:xfrm>
-            <a:off x="1143000" y="3429000"/>
+            <a:off x="1143000" y="3942568"/>
             <a:ext cx="6858000" cy="2203244"/>
           </a:xfrm>
         </p:spPr>
@@ -2946,18 +4166,6 @@
               </a:rPr>
               <a:t>Cameron Yeagle</a:t>
             </a:r>
-          </a:p>
-          <a:p>
-            <a:endParaRPr lang="en-US" sz="2800" dirty="0">
-              <a:solidFill>
-                <a:schemeClr val="tx2">
-                  <a:lumMod val="60000"/>
-                  <a:lumOff val="40000"/>
-                </a:schemeClr>
-              </a:solidFill>
-              <a:latin typeface="Arial" panose="020B0604020202020204" pitchFamily="34" charset="0"/>
-              <a:cs typeface="Arial" panose="020B0604020202020204" pitchFamily="34" charset="0"/>
-            </a:endParaRPr>
           </a:p>
           <a:p>
             <a:r>
@@ -3012,6 +4220,37 @@
           <a:chExt cx="0" cy="0"/>
         </a:xfrm>
       </p:grpSpPr>
+      <p:pic>
+        <p:nvPicPr>
+          <p:cNvPr id="3" name="Picture 2">
+            <a:extLst>
+              <a:ext uri="{FF2B5EF4-FFF2-40B4-BE49-F238E27FC236}">
+                <a16:creationId xmlns:a16="http://schemas.microsoft.com/office/drawing/2014/main" id="{359E8AF3-CD0B-34F4-71ED-42BA0834C6ED}"/>
+              </a:ext>
+            </a:extLst>
+          </p:cNvPr>
+          <p:cNvPicPr>
+            <a:picLocks noChangeAspect="1"/>
+          </p:cNvPicPr>
+          <p:nvPr/>
+        </p:nvPicPr>
+        <p:blipFill>
+          <a:blip r:embed="rId3"/>
+          <a:srcRect b="6116"/>
+          <a:stretch>
+            <a:fillRect/>
+          </a:stretch>
+        </p:blipFill>
+        <p:spPr>
+          <a:xfrm>
+            <a:off x="1826407" y="1341828"/>
+            <a:ext cx="7126062" cy="4683190"/>
+          </a:xfrm>
+          <a:prstGeom prst="rect">
+            <a:avLst/>
+          </a:prstGeom>
+        </p:spPr>
+      </p:pic>
       <p:sp>
         <p:nvSpPr>
           <p:cNvPr id="10" name="Title 9">
@@ -3030,7 +4269,7 @@
         </p:nvSpPr>
         <p:spPr>
           <a:xfrm>
-            <a:off x="457200" y="234751"/>
+            <a:off x="442982" y="347656"/>
             <a:ext cx="7886700" cy="994172"/>
           </a:xfrm>
         </p:spPr>
@@ -3048,7 +4287,7 @@
                 <a:latin typeface="Arial" panose="020B0604020202020204" pitchFamily="34" charset="0"/>
                 <a:cs typeface="Arial" panose="020B0604020202020204" pitchFamily="34" charset="0"/>
               </a:rPr>
-              <a:t>Updated Deformation </a:t>
+              <a:t>Model Forces</a:t>
             </a:r>
           </a:p>
         </p:txBody>
@@ -3090,299 +4329,16 @@
           </a:fontRef>
         </p:style>
       </p:cxnSp>
-      <p:pic>
-        <p:nvPicPr>
-          <p:cNvPr id="3" name="lower_prof">
-            <a:hlinkClick r:id="" action="ppaction://media"/>
-            <a:extLst>
-              <a:ext uri="{FF2B5EF4-FFF2-40B4-BE49-F238E27FC236}">
-                <a16:creationId xmlns:a16="http://schemas.microsoft.com/office/drawing/2014/main" id="{62A85324-B546-FC18-A3C0-2083630F2093}"/>
-              </a:ext>
-            </a:extLst>
-          </p:cNvPr>
-          <p:cNvPicPr>
-            <a:picLocks noChangeAspect="1"/>
-          </p:cNvPicPr>
-          <p:nvPr>
-            <a:videoFile r:link="rId2"/>
-            <p:extLst>
-              <p:ext uri="{DAA4B4D4-6D71-4841-9C94-3DE7FCFB9230}">
-                <p14:media xmlns:p14="http://schemas.microsoft.com/office/powerpoint/2010/main" r:embed="rId1"/>
-              </p:ext>
-            </p:extLst>
-          </p:nvPr>
-        </p:nvPicPr>
-        <p:blipFill>
-          <a:blip r:embed="rId5"/>
-          <a:srcRect l="27397" t="10122" r="33698" b="19011"/>
-          <a:stretch>
-            <a:fillRect/>
-          </a:stretch>
-        </p:blipFill>
-        <p:spPr>
-          <a:xfrm>
-            <a:off x="3457183" y="1338525"/>
-            <a:ext cx="5049556" cy="5174015"/>
-          </a:xfrm>
-          <a:prstGeom prst="rect">
-            <a:avLst/>
-          </a:prstGeom>
-        </p:spPr>
-      </p:pic>
-      <p:sp>
-        <p:nvSpPr>
-          <p:cNvPr id="4" name="TextBox 3">
-            <a:extLst>
-              <a:ext uri="{FF2B5EF4-FFF2-40B4-BE49-F238E27FC236}">
-                <a16:creationId xmlns:a16="http://schemas.microsoft.com/office/drawing/2014/main" id="{F20D4BC1-E94F-BAA2-9DB2-64545DDBDB52}"/>
-              </a:ext>
-            </a:extLst>
-          </p:cNvPr>
-          <p:cNvSpPr txBox="1"/>
-          <p:nvPr/>
-        </p:nvSpPr>
-        <p:spPr>
-          <a:xfrm>
-            <a:off x="457200" y="1717589"/>
-            <a:ext cx="2999983" cy="3416320"/>
-          </a:xfrm>
-          <a:prstGeom prst="rect">
-            <a:avLst/>
-          </a:prstGeom>
-          <a:noFill/>
-        </p:spPr>
-        <p:txBody>
-          <a:bodyPr wrap="square" rtlCol="0">
-            <a:spAutoFit/>
-          </a:bodyPr>
-          <a:lstStyle/>
-          <a:p>
-            <a:r>
-              <a:rPr lang="en-US" sz="2400" dirty="0">
-                <a:solidFill>
-                  <a:schemeClr val="tx2"/>
-                </a:solidFill>
-              </a:rPr>
-              <a:t>Spring Constants: </a:t>
-            </a:r>
-          </a:p>
-          <a:p>
-            <a:pPr marL="800100" lvl="1" indent="-342900">
-              <a:buFont typeface="Arial" panose="020B0604020202020204" pitchFamily="34" charset="0"/>
-              <a:buChar char="•"/>
-            </a:pPr>
-            <a:r>
-              <a:rPr lang="en-US" sz="2400" dirty="0">
-                <a:solidFill>
-                  <a:schemeClr val="tx2"/>
-                </a:solidFill>
-              </a:rPr>
-              <a:t>BM-to-Cell = .005</a:t>
-            </a:r>
-          </a:p>
-          <a:p>
-            <a:pPr marL="800100" lvl="1" indent="-342900">
-              <a:buFont typeface="Arial" panose="020B0604020202020204" pitchFamily="34" charset="0"/>
-              <a:buChar char="•"/>
-            </a:pPr>
-            <a:r>
-              <a:rPr lang="en-US" sz="2400" dirty="0">
-                <a:solidFill>
-                  <a:schemeClr val="tx2"/>
-                </a:solidFill>
-              </a:rPr>
-              <a:t>Cell-to-BM = .005</a:t>
-            </a:r>
-          </a:p>
-          <a:p>
-            <a:pPr marL="800100" lvl="1" indent="-342900">
-              <a:buFont typeface="Arial" panose="020B0604020202020204" pitchFamily="34" charset="0"/>
-              <a:buChar char="•"/>
-            </a:pPr>
-            <a:r>
-              <a:rPr lang="en-US" sz="2400" dirty="0">
-                <a:solidFill>
-                  <a:schemeClr val="tx2"/>
-                </a:solidFill>
-              </a:rPr>
-              <a:t>Repulsion = 1</a:t>
-            </a:r>
-          </a:p>
-          <a:p>
-            <a:endParaRPr lang="en-US" sz="2400" dirty="0">
-              <a:solidFill>
-                <a:schemeClr val="tx2"/>
-              </a:solidFill>
-            </a:endParaRPr>
-          </a:p>
-          <a:p>
-            <a:r>
-              <a:rPr lang="en-US" sz="2400" dirty="0">
-                <a:solidFill>
-                  <a:schemeClr val="tx2"/>
-                </a:solidFill>
-              </a:rPr>
-              <a:t>Proliferation = .001</a:t>
-            </a:r>
-          </a:p>
-          <a:p>
-            <a:pPr marL="800100" lvl="1" indent="-342900">
-              <a:buFont typeface="Arial" panose="020B0604020202020204" pitchFamily="34" charset="0"/>
-              <a:buChar char="•"/>
-            </a:pPr>
-            <a:endParaRPr lang="en-US" sz="2400" dirty="0">
-              <a:solidFill>
-                <a:schemeClr val="tx2"/>
-              </a:solidFill>
-            </a:endParaRPr>
-          </a:p>
-        </p:txBody>
-      </p:sp>
     </p:spTree>
     <p:extLst>
       <p:ext uri="{BB962C8B-B14F-4D97-AF65-F5344CB8AC3E}">
-        <p14:creationId xmlns:p14="http://schemas.microsoft.com/office/powerpoint/2010/main" val="1276417643"/>
+        <p14:creationId xmlns:p14="http://schemas.microsoft.com/office/powerpoint/2010/main" val="3990933769"/>
       </p:ext>
     </p:extLst>
   </p:cSld>
   <p:clrMapOvr>
     <a:masterClrMapping/>
   </p:clrMapOvr>
-  <p:timing>
-    <p:tnLst>
-      <p:par>
-        <p:cTn id="1" dur="indefinite" restart="never" nodeType="tmRoot">
-          <p:childTnLst>
-            <p:seq concurrent="1" nextAc="seek">
-              <p:cTn id="2" dur="indefinite" nodeType="mainSeq">
-                <p:childTnLst>
-                  <p:par>
-                    <p:cTn id="3" fill="hold">
-                      <p:stCondLst>
-                        <p:cond delay="indefinite"/>
-                      </p:stCondLst>
-                      <p:childTnLst>
-                        <p:par>
-                          <p:cTn id="4" fill="hold">
-                            <p:stCondLst>
-                              <p:cond delay="0"/>
-                            </p:stCondLst>
-                            <p:childTnLst>
-                              <p:par>
-                                <p:cTn id="5" presetID="1" presetClass="mediacall" presetSubtype="0" fill="hold" nodeType="clickEffect">
-                                  <p:stCondLst>
-                                    <p:cond delay="0"/>
-                                  </p:stCondLst>
-                                  <p:childTnLst>
-                                    <p:cmd type="call" cmd="playFrom(0.0)">
-                                      <p:cBhvr>
-                                        <p:cTn id="6" dur="34743" fill="hold"/>
-                                        <p:tgtEl>
-                                          <p:spTgt spid="3"/>
-                                        </p:tgtEl>
-                                      </p:cBhvr>
-                                    </p:cmd>
-                                  </p:childTnLst>
-                                </p:cTn>
-                              </p:par>
-                            </p:childTnLst>
-                          </p:cTn>
-                        </p:par>
-                      </p:childTnLst>
-                    </p:cTn>
-                  </p:par>
-                </p:childTnLst>
-              </p:cTn>
-              <p:prevCondLst>
-                <p:cond evt="onPrev" delay="0">
-                  <p:tgtEl>
-                    <p:sldTgt/>
-                  </p:tgtEl>
-                </p:cond>
-              </p:prevCondLst>
-              <p:nextCondLst>
-                <p:cond evt="onNext" delay="0">
-                  <p:tgtEl>
-                    <p:sldTgt/>
-                  </p:tgtEl>
-                </p:cond>
-              </p:nextCondLst>
-            </p:seq>
-            <p:video>
-              <p:cMediaNode vol="80000">
-                <p:cTn id="7" fill="hold" display="0">
-                  <p:stCondLst>
-                    <p:cond delay="indefinite"/>
-                  </p:stCondLst>
-                </p:cTn>
-                <p:tgtEl>
-                  <p:spTgt spid="3"/>
-                </p:tgtEl>
-              </p:cMediaNode>
-            </p:video>
-            <p:seq concurrent="1" nextAc="seek">
-              <p:cTn id="8" restart="whenNotActive" fill="hold" evtFilter="cancelBubble" nodeType="interactiveSeq">
-                <p:stCondLst>
-                  <p:cond evt="onClick" delay="0">
-                    <p:tgtEl>
-                      <p:spTgt spid="3"/>
-                    </p:tgtEl>
-                  </p:cond>
-                </p:stCondLst>
-                <p:endSync evt="end" delay="0">
-                  <p:rtn val="all"/>
-                </p:endSync>
-                <p:childTnLst>
-                  <p:par>
-                    <p:cTn id="9" fill="hold">
-                      <p:stCondLst>
-                        <p:cond delay="0"/>
-                      </p:stCondLst>
-                      <p:childTnLst>
-                        <p:par>
-                          <p:cTn id="10" fill="hold">
-                            <p:stCondLst>
-                              <p:cond delay="0"/>
-                            </p:stCondLst>
-                            <p:childTnLst>
-                              <p:par>
-                                <p:cTn id="11" presetID="2" presetClass="mediacall" presetSubtype="0" fill="hold" nodeType="clickEffect">
-                                  <p:stCondLst>
-                                    <p:cond delay="0"/>
-                                  </p:stCondLst>
-                                  <p:childTnLst>
-                                    <p:cmd type="call" cmd="togglePause">
-                                      <p:cBhvr>
-                                        <p:cTn id="12" dur="1" fill="hold"/>
-                                        <p:tgtEl>
-                                          <p:spTgt spid="3"/>
-                                        </p:tgtEl>
-                                      </p:cBhvr>
-                                    </p:cmd>
-                                  </p:childTnLst>
-                                </p:cTn>
-                              </p:par>
-                            </p:childTnLst>
-                          </p:cTn>
-                        </p:par>
-                      </p:childTnLst>
-                    </p:cTn>
-                  </p:par>
-                </p:childTnLst>
-              </p:cTn>
-              <p:nextCondLst>
-                <p:cond evt="onClick" delay="0">
-                  <p:tgtEl>
-                    <p:spTgt spid="3"/>
-                  </p:tgtEl>
-                </p:cond>
-              </p:nextCondLst>
-            </p:seq>
-          </p:childTnLst>
-        </p:cTn>
-      </p:par>
-    </p:tnLst>
-  </p:timing>
 </p:sld>
 </file>
 
@@ -3394,7 +4350,7 @@
         <p:cNvPr id="1" name="">
           <a:extLst>
             <a:ext uri="{FF2B5EF4-FFF2-40B4-BE49-F238E27FC236}">
-              <a16:creationId xmlns:a16="http://schemas.microsoft.com/office/drawing/2014/main" id="{D2D1A48A-8F25-B2AB-40D5-620262D66B20}"/>
+              <a16:creationId xmlns:a16="http://schemas.microsoft.com/office/drawing/2014/main" id="{79344FAA-7F5F-93B6-06BA-45FFB4901E20}"/>
             </a:ext>
           </a:extLst>
         </p:cNvPr>
@@ -3414,7 +4370,7 @@
           <p:cNvPr id="10" name="Title 9">
             <a:extLst>
               <a:ext uri="{FF2B5EF4-FFF2-40B4-BE49-F238E27FC236}">
-                <a16:creationId xmlns:a16="http://schemas.microsoft.com/office/drawing/2014/main" id="{1C95EC67-C641-5091-7EC0-DA15C688D1F3}"/>
+                <a16:creationId xmlns:a16="http://schemas.microsoft.com/office/drawing/2014/main" id="{AB4AA6EF-D9B2-D827-3156-B6C99CE3EA7C}"/>
               </a:ext>
             </a:extLst>
           </p:cNvPr>
@@ -3427,7 +4383,7 @@
         </p:nvSpPr>
         <p:spPr>
           <a:xfrm>
-            <a:off x="457200" y="234751"/>
+            <a:off x="457200" y="331927"/>
             <a:ext cx="7886700" cy="994172"/>
           </a:xfrm>
         </p:spPr>
@@ -3445,7 +4401,7 @@
                 <a:latin typeface="Arial" panose="020B0604020202020204" pitchFamily="34" charset="0"/>
                 <a:cs typeface="Arial" panose="020B0604020202020204" pitchFamily="34" charset="0"/>
               </a:rPr>
-              <a:t>Updated Deformation </a:t>
+              <a:t>BM-Cell Interactions</a:t>
             </a:r>
           </a:p>
         </p:txBody>
@@ -3455,7 +4411,2446 @@
           <p:cNvPr id="5" name="Straight Connector 4">
             <a:extLst>
               <a:ext uri="{FF2B5EF4-FFF2-40B4-BE49-F238E27FC236}">
-                <a16:creationId xmlns:a16="http://schemas.microsoft.com/office/drawing/2014/main" id="{6161F00D-CD6D-1275-3333-ED17AE5260BC}"/>
+                <a16:creationId xmlns:a16="http://schemas.microsoft.com/office/drawing/2014/main" id="{3B880F1D-C881-0D18-030B-59B04C97ADBC}"/>
+              </a:ext>
+            </a:extLst>
+          </p:cNvPr>
+          <p:cNvCxnSpPr/>
+          <p:nvPr/>
+        </p:nvCxnSpPr>
+        <p:spPr>
+          <a:xfrm>
+            <a:off x="191528" y="1224990"/>
+            <a:ext cx="8760941" cy="0"/>
+          </a:xfrm>
+          <a:prstGeom prst="line">
+            <a:avLst/>
+          </a:prstGeom>
+          <a:ln w="38100"/>
+        </p:spPr>
+        <p:style>
+          <a:lnRef idx="1">
+            <a:schemeClr val="accent1"/>
+          </a:lnRef>
+          <a:fillRef idx="0">
+            <a:schemeClr val="accent1"/>
+          </a:fillRef>
+          <a:effectRef idx="0">
+            <a:schemeClr val="accent1"/>
+          </a:effectRef>
+          <a:fontRef idx="minor">
+            <a:schemeClr val="tx1"/>
+          </a:fontRef>
+        </p:style>
+      </p:cxnSp>
+      <p:pic>
+        <p:nvPicPr>
+          <p:cNvPr id="3" name="Picture 2">
+            <a:extLst>
+              <a:ext uri="{FF2B5EF4-FFF2-40B4-BE49-F238E27FC236}">
+                <a16:creationId xmlns:a16="http://schemas.microsoft.com/office/drawing/2014/main" id="{35ACF48A-58A0-FED4-F0C4-DDCBC82C4AD6}"/>
+              </a:ext>
+            </a:extLst>
+          </p:cNvPr>
+          <p:cNvPicPr>
+            <a:picLocks noChangeAspect="1"/>
+          </p:cNvPicPr>
+          <p:nvPr/>
+        </p:nvPicPr>
+        <p:blipFill>
+          <a:blip r:embed="rId3"/>
+          <a:srcRect l="11370" r="14795" b="6311"/>
+          <a:stretch>
+            <a:fillRect/>
+          </a:stretch>
+        </p:blipFill>
+        <p:spPr>
+          <a:xfrm>
+            <a:off x="4246324" y="1853281"/>
+            <a:ext cx="4255402" cy="3779729"/>
+          </a:xfrm>
+          <a:prstGeom prst="rect">
+            <a:avLst/>
+          </a:prstGeom>
+        </p:spPr>
+      </p:pic>
+      <p:sp>
+        <p:nvSpPr>
+          <p:cNvPr id="6" name="Content Placeholder 2">
+            <a:extLst>
+              <a:ext uri="{FF2B5EF4-FFF2-40B4-BE49-F238E27FC236}">
+                <a16:creationId xmlns:a16="http://schemas.microsoft.com/office/drawing/2014/main" id="{76E67268-EC7F-10AB-1A82-7BC4F2DA4F99}"/>
+              </a:ext>
+            </a:extLst>
+          </p:cNvPr>
+          <p:cNvSpPr txBox="1">
+            <a:spLocks/>
+          </p:cNvSpPr>
+          <p:nvPr/>
+        </p:nvSpPr>
+        <p:spPr>
+          <a:xfrm>
+            <a:off x="457200" y="1718628"/>
+            <a:ext cx="3723145" cy="4049034"/>
+          </a:xfrm>
+          <a:prstGeom prst="rect">
+            <a:avLst/>
+          </a:prstGeom>
+        </p:spPr>
+        <p:txBody>
+          <a:bodyPr vert="horz" lIns="91440" tIns="45720" rIns="91440" bIns="45720" rtlCol="0">
+            <a:normAutofit lnSpcReduction="10000"/>
+          </a:bodyPr>
+          <a:lstStyle>
+            <a:lvl1pPr marL="171450" indent="-171450" algn="l" defTabSz="685800" rtl="0" eaLnBrk="1" latinLnBrk="0" hangingPunct="1">
+              <a:lnSpc>
+                <a:spcPct val="90000"/>
+              </a:lnSpc>
+              <a:spcBef>
+                <a:spcPts val="750"/>
+              </a:spcBef>
+              <a:buFont typeface="Arial" panose="020B0604020202020204" pitchFamily="34" charset="0"/>
+              <a:buChar char="•"/>
+              <a:defRPr sz="2100" b="0" i="0" kern="1200">
+                <a:solidFill>
+                  <a:schemeClr val="tx1"/>
+                </a:solidFill>
+                <a:latin typeface="+mn-lt"/>
+                <a:ea typeface="+mn-ea"/>
+                <a:cs typeface="+mn-cs"/>
+              </a:defRPr>
+            </a:lvl1pPr>
+            <a:lvl2pPr marL="514350" indent="-171450" algn="l" defTabSz="685800" rtl="0" eaLnBrk="1" latinLnBrk="0" hangingPunct="1">
+              <a:lnSpc>
+                <a:spcPct val="90000"/>
+              </a:lnSpc>
+              <a:spcBef>
+                <a:spcPts val="375"/>
+              </a:spcBef>
+              <a:buFont typeface="Arial" panose="020B0604020202020204" pitchFamily="34" charset="0"/>
+              <a:buChar char="•"/>
+              <a:defRPr sz="1800" b="0" i="0" kern="1200">
+                <a:solidFill>
+                  <a:schemeClr val="tx1"/>
+                </a:solidFill>
+                <a:latin typeface="+mn-lt"/>
+                <a:ea typeface="+mn-ea"/>
+                <a:cs typeface="+mn-cs"/>
+              </a:defRPr>
+            </a:lvl2pPr>
+            <a:lvl3pPr marL="857250" indent="-171450" algn="l" defTabSz="685800" rtl="0" eaLnBrk="1" latinLnBrk="0" hangingPunct="1">
+              <a:lnSpc>
+                <a:spcPct val="90000"/>
+              </a:lnSpc>
+              <a:spcBef>
+                <a:spcPts val="375"/>
+              </a:spcBef>
+              <a:buFont typeface="Arial" panose="020B0604020202020204" pitchFamily="34" charset="0"/>
+              <a:buChar char="•"/>
+              <a:defRPr sz="1500" b="0" i="0" kern="1200">
+                <a:solidFill>
+                  <a:schemeClr val="tx1"/>
+                </a:solidFill>
+                <a:latin typeface="+mn-lt"/>
+                <a:ea typeface="+mn-ea"/>
+                <a:cs typeface="+mn-cs"/>
+              </a:defRPr>
+            </a:lvl3pPr>
+            <a:lvl4pPr marL="1200150" indent="-171450" algn="l" defTabSz="685800" rtl="0" eaLnBrk="1" latinLnBrk="0" hangingPunct="1">
+              <a:lnSpc>
+                <a:spcPct val="90000"/>
+              </a:lnSpc>
+              <a:spcBef>
+                <a:spcPts val="375"/>
+              </a:spcBef>
+              <a:buFont typeface="Arial" panose="020B0604020202020204" pitchFamily="34" charset="0"/>
+              <a:buChar char="•"/>
+              <a:defRPr sz="1350" b="0" i="0" kern="1200">
+                <a:solidFill>
+                  <a:schemeClr val="tx1"/>
+                </a:solidFill>
+                <a:latin typeface="+mn-lt"/>
+                <a:ea typeface="+mn-ea"/>
+                <a:cs typeface="+mn-cs"/>
+              </a:defRPr>
+            </a:lvl4pPr>
+            <a:lvl5pPr marL="1543050" indent="-171450" algn="l" defTabSz="685800" rtl="0" eaLnBrk="1" latinLnBrk="0" hangingPunct="1">
+              <a:lnSpc>
+                <a:spcPct val="90000"/>
+              </a:lnSpc>
+              <a:spcBef>
+                <a:spcPts val="375"/>
+              </a:spcBef>
+              <a:buFont typeface="Arial" panose="020B0604020202020204" pitchFamily="34" charset="0"/>
+              <a:buChar char="•"/>
+              <a:defRPr sz="1350" b="0" i="0" kern="1200">
+                <a:solidFill>
+                  <a:schemeClr val="tx1"/>
+                </a:solidFill>
+                <a:latin typeface="+mn-lt"/>
+                <a:ea typeface="+mn-ea"/>
+                <a:cs typeface="+mn-cs"/>
+              </a:defRPr>
+            </a:lvl5pPr>
+            <a:lvl6pPr marL="1885950" indent="-171450" algn="l" defTabSz="685800" rtl="0" eaLnBrk="1" latinLnBrk="0" hangingPunct="1">
+              <a:lnSpc>
+                <a:spcPct val="90000"/>
+              </a:lnSpc>
+              <a:spcBef>
+                <a:spcPts val="375"/>
+              </a:spcBef>
+              <a:buFont typeface="Arial" panose="020B0604020202020204" pitchFamily="34" charset="0"/>
+              <a:buChar char="•"/>
+              <a:defRPr sz="1350" kern="1200">
+                <a:solidFill>
+                  <a:schemeClr val="tx1"/>
+                </a:solidFill>
+                <a:latin typeface="+mn-lt"/>
+                <a:ea typeface="+mn-ea"/>
+                <a:cs typeface="+mn-cs"/>
+              </a:defRPr>
+            </a:lvl6pPr>
+            <a:lvl7pPr marL="2228850" indent="-171450" algn="l" defTabSz="685800" rtl="0" eaLnBrk="1" latinLnBrk="0" hangingPunct="1">
+              <a:lnSpc>
+                <a:spcPct val="90000"/>
+              </a:lnSpc>
+              <a:spcBef>
+                <a:spcPts val="375"/>
+              </a:spcBef>
+              <a:buFont typeface="Arial" panose="020B0604020202020204" pitchFamily="34" charset="0"/>
+              <a:buChar char="•"/>
+              <a:defRPr sz="1350" kern="1200">
+                <a:solidFill>
+                  <a:schemeClr val="tx1"/>
+                </a:solidFill>
+                <a:latin typeface="+mn-lt"/>
+                <a:ea typeface="+mn-ea"/>
+                <a:cs typeface="+mn-cs"/>
+              </a:defRPr>
+            </a:lvl7pPr>
+            <a:lvl8pPr marL="2571750" indent="-171450" algn="l" defTabSz="685800" rtl="0" eaLnBrk="1" latinLnBrk="0" hangingPunct="1">
+              <a:lnSpc>
+                <a:spcPct val="90000"/>
+              </a:lnSpc>
+              <a:spcBef>
+                <a:spcPts val="375"/>
+              </a:spcBef>
+              <a:buFont typeface="Arial" panose="020B0604020202020204" pitchFamily="34" charset="0"/>
+              <a:buChar char="•"/>
+              <a:defRPr sz="1350" kern="1200">
+                <a:solidFill>
+                  <a:schemeClr val="tx1"/>
+                </a:solidFill>
+                <a:latin typeface="+mn-lt"/>
+                <a:ea typeface="+mn-ea"/>
+                <a:cs typeface="+mn-cs"/>
+              </a:defRPr>
+            </a:lvl8pPr>
+            <a:lvl9pPr marL="2914650" indent="-171450" algn="l" defTabSz="685800" rtl="0" eaLnBrk="1" latinLnBrk="0" hangingPunct="1">
+              <a:lnSpc>
+                <a:spcPct val="90000"/>
+              </a:lnSpc>
+              <a:spcBef>
+                <a:spcPts val="375"/>
+              </a:spcBef>
+              <a:buFont typeface="Arial" panose="020B0604020202020204" pitchFamily="34" charset="0"/>
+              <a:buChar char="•"/>
+              <a:defRPr sz="1350" kern="1200">
+                <a:solidFill>
+                  <a:schemeClr val="tx1"/>
+                </a:solidFill>
+                <a:latin typeface="+mn-lt"/>
+                <a:ea typeface="+mn-ea"/>
+                <a:cs typeface="+mn-cs"/>
+              </a:defRPr>
+            </a:lvl9pPr>
+          </a:lstStyle>
+          <a:p>
+            <a:pPr>
+              <a:spcAft>
+                <a:spcPts val="1200"/>
+              </a:spcAft>
+            </a:pPr>
+            <a:r>
+              <a:rPr lang="en-US" sz="3500" dirty="0"/>
+              <a:t>BM is made up of </a:t>
+            </a:r>
+            <a:r>
+              <a:rPr lang="en-US" sz="3500" b="1" dirty="0">
+                <a:solidFill>
+                  <a:schemeClr val="tx2"/>
+                </a:solidFill>
+              </a:rPr>
+              <a:t>Laminin</a:t>
+            </a:r>
+            <a:r>
+              <a:rPr lang="en-US" sz="3500" dirty="0"/>
+              <a:t> and </a:t>
+            </a:r>
+            <a:r>
+              <a:rPr lang="en-US" sz="3500" b="1" dirty="0">
+                <a:solidFill>
+                  <a:schemeClr val="tx2"/>
+                </a:solidFill>
+              </a:rPr>
+              <a:t>Collogen IV </a:t>
+            </a:r>
+            <a:r>
+              <a:rPr lang="en-US" sz="3500" dirty="0"/>
+              <a:t>[1]</a:t>
+            </a:r>
+          </a:p>
+          <a:p>
+            <a:pPr lvl="1">
+              <a:spcAft>
+                <a:spcPts val="1200"/>
+              </a:spcAft>
+            </a:pPr>
+            <a:r>
+              <a:rPr lang="en-US" sz="3200" dirty="0"/>
+              <a:t> Laminin binds to </a:t>
+            </a:r>
+            <a:r>
+              <a:rPr lang="en-US" sz="3200" b="1" dirty="0">
+                <a:solidFill>
+                  <a:schemeClr val="tx2"/>
+                </a:solidFill>
+              </a:rPr>
+              <a:t>Integrin</a:t>
+            </a:r>
+            <a:r>
+              <a:rPr lang="en-US" sz="3200" dirty="0"/>
+              <a:t> proteins</a:t>
+            </a:r>
+          </a:p>
+          <a:p>
+            <a:r>
+              <a:rPr lang="en-US" sz="3500" dirty="0"/>
+              <a:t>Represented by a </a:t>
+            </a:r>
+            <a:r>
+              <a:rPr lang="en-US" sz="3500" b="1" dirty="0">
+                <a:solidFill>
+                  <a:schemeClr val="tx2"/>
+                </a:solidFill>
+              </a:rPr>
+              <a:t>Hookean Force </a:t>
+            </a:r>
+            <a:r>
+              <a:rPr lang="en-US" sz="3500" dirty="0"/>
+              <a:t>(F=-</a:t>
+            </a:r>
+            <a:r>
+              <a:rPr lang="en-US" sz="3500" dirty="0" err="1"/>
+              <a:t>kx</a:t>
+            </a:r>
+            <a:r>
+              <a:rPr lang="en-US" sz="3500" dirty="0"/>
+              <a:t>)</a:t>
+            </a:r>
+          </a:p>
+          <a:p>
+            <a:pPr marL="0" indent="0">
+              <a:buNone/>
+            </a:pPr>
+            <a:endParaRPr lang="en-US" sz="3500" b="1" dirty="0">
+              <a:solidFill>
+                <a:srgbClr val="FF0000"/>
+              </a:solidFill>
+            </a:endParaRPr>
+          </a:p>
+          <a:p>
+            <a:endParaRPr lang="en-US" sz="3200" dirty="0"/>
+          </a:p>
+        </p:txBody>
+      </p:sp>
+      <p:sp>
+        <p:nvSpPr>
+          <p:cNvPr id="4" name="TextBox 3">
+            <a:extLst>
+              <a:ext uri="{FF2B5EF4-FFF2-40B4-BE49-F238E27FC236}">
+                <a16:creationId xmlns:a16="http://schemas.microsoft.com/office/drawing/2014/main" id="{F76D8CBC-4ADA-203E-2AE6-3527E6ABB36E}"/>
+              </a:ext>
+            </a:extLst>
+          </p:cNvPr>
+          <p:cNvSpPr txBox="1"/>
+          <p:nvPr/>
+        </p:nvSpPr>
+        <p:spPr>
+          <a:xfrm>
+            <a:off x="2868460" y="5633010"/>
+            <a:ext cx="6084009" cy="923330"/>
+          </a:xfrm>
+          <a:prstGeom prst="rect">
+            <a:avLst/>
+          </a:prstGeom>
+          <a:noFill/>
+        </p:spPr>
+        <p:txBody>
+          <a:bodyPr wrap="square" rtlCol="0">
+            <a:spAutoFit/>
+          </a:bodyPr>
+          <a:lstStyle/>
+          <a:p>
+            <a:r>
+              <a:rPr lang="en-US" sz="1200" dirty="0">
+                <a:solidFill>
+                  <a:srgbClr val="1B1B1B"/>
+                </a:solidFill>
+                <a:latin typeface="Roboto Mono Web"/>
+              </a:rPr>
+              <a:t>[1] </a:t>
+            </a:r>
+            <a:r>
+              <a:rPr lang="en-US" sz="1200" dirty="0" err="1">
+                <a:solidFill>
+                  <a:srgbClr val="1B1B1B"/>
+                </a:solidFill>
+                <a:latin typeface="Roboto Mono Web"/>
+              </a:rPr>
+              <a:t>Yurchenco</a:t>
+            </a:r>
+            <a:r>
+              <a:rPr lang="en-US" sz="1200" dirty="0">
+                <a:solidFill>
+                  <a:srgbClr val="1B1B1B"/>
+                </a:solidFill>
+                <a:latin typeface="Roboto Mono Web"/>
+              </a:rPr>
+              <a:t> PD, Patton BL. Developmental and pathogenic mechanisms of basement membrane assembly. Curr Pharm Des. 2009;15(12):1277-94. </a:t>
+            </a:r>
+            <a:r>
+              <a:rPr lang="en-US" sz="1200" dirty="0" err="1">
+                <a:solidFill>
+                  <a:srgbClr val="1B1B1B"/>
+                </a:solidFill>
+                <a:latin typeface="Roboto Mono Web"/>
+              </a:rPr>
+              <a:t>doi</a:t>
+            </a:r>
+            <a:r>
+              <a:rPr lang="en-US" sz="1200" dirty="0">
+                <a:solidFill>
+                  <a:srgbClr val="1B1B1B"/>
+                </a:solidFill>
+                <a:latin typeface="Roboto Mono Web"/>
+              </a:rPr>
+              <a:t>: 10.2174/138161209787846766. PMID: 19355968; PMCID: PMC2978668.</a:t>
+            </a:r>
+          </a:p>
+          <a:p>
+            <a:endParaRPr lang="en-US" dirty="0"/>
+          </a:p>
+        </p:txBody>
+      </p:sp>
+    </p:spTree>
+    <p:extLst>
+      <p:ext uri="{BB962C8B-B14F-4D97-AF65-F5344CB8AC3E}">
+        <p14:creationId xmlns:p14="http://schemas.microsoft.com/office/powerpoint/2010/main" val="3432670249"/>
+      </p:ext>
+    </p:extLst>
+  </p:cSld>
+  <p:clrMapOvr>
+    <a:masterClrMapping/>
+  </p:clrMapOvr>
+</p:sld>
+</file>
+
+<file path=ppt/slides/slide4.xml><?xml version="1.0" encoding="utf-8"?>
+<p:sld xmlns:a="http://schemas.openxmlformats.org/drawingml/2006/main" xmlns:r="http://schemas.openxmlformats.org/officeDocument/2006/relationships" xmlns:p="http://schemas.openxmlformats.org/presentationml/2006/main">
+  <p:cSld>
+    <p:spTree>
+      <p:nvGrpSpPr>
+        <p:cNvPr id="1" name="">
+          <a:extLst>
+            <a:ext uri="{FF2B5EF4-FFF2-40B4-BE49-F238E27FC236}">
+              <a16:creationId xmlns:a16="http://schemas.microsoft.com/office/drawing/2014/main" id="{DA9F196E-86F8-C57B-BBE3-7B0B597AAAD5}"/>
+            </a:ext>
+          </a:extLst>
+        </p:cNvPr>
+        <p:cNvGrpSpPr/>
+        <p:nvPr/>
+      </p:nvGrpSpPr>
+      <p:grpSpPr>
+        <a:xfrm>
+          <a:off x="0" y="0"/>
+          <a:ext cx="0" cy="0"/>
+          <a:chOff x="0" y="0"/>
+          <a:chExt cx="0" cy="0"/>
+        </a:xfrm>
+      </p:grpSpPr>
+      <p:sp>
+        <p:nvSpPr>
+          <p:cNvPr id="10" name="Title 9">
+            <a:extLst>
+              <a:ext uri="{FF2B5EF4-FFF2-40B4-BE49-F238E27FC236}">
+                <a16:creationId xmlns:a16="http://schemas.microsoft.com/office/drawing/2014/main" id="{BB4D4769-2D9B-4109-45AD-30C6C2B68C9C}"/>
+              </a:ext>
+            </a:extLst>
+          </p:cNvPr>
+          <p:cNvSpPr>
+            <a:spLocks noGrp="1"/>
+          </p:cNvSpPr>
+          <p:nvPr>
+            <p:ph type="title"/>
+          </p:nvPr>
+        </p:nvSpPr>
+        <p:spPr>
+          <a:xfrm>
+            <a:off x="457200" y="331927"/>
+            <a:ext cx="7886700" cy="994172"/>
+          </a:xfrm>
+        </p:spPr>
+        <p:txBody>
+          <a:bodyPr>
+            <a:noAutofit/>
+          </a:bodyPr>
+          <a:lstStyle/>
+          <a:p>
+            <a:r>
+              <a:rPr lang="en-US" sz="3200" b="1" dirty="0">
+                <a:solidFill>
+                  <a:srgbClr val="171C8C"/>
+                </a:solidFill>
+                <a:latin typeface="Arial" panose="020B0604020202020204" pitchFamily="34" charset="0"/>
+                <a:cs typeface="Arial" panose="020B0604020202020204" pitchFamily="34" charset="0"/>
+              </a:rPr>
+              <a:t>Cell-BM Interactions</a:t>
+            </a:r>
+          </a:p>
+        </p:txBody>
+      </p:sp>
+      <p:cxnSp>
+        <p:nvCxnSpPr>
+          <p:cNvPr id="5" name="Straight Connector 4">
+            <a:extLst>
+              <a:ext uri="{FF2B5EF4-FFF2-40B4-BE49-F238E27FC236}">
+                <a16:creationId xmlns:a16="http://schemas.microsoft.com/office/drawing/2014/main" id="{D53766FA-8E89-3E2C-A930-91B65AF195C7}"/>
+              </a:ext>
+            </a:extLst>
+          </p:cNvPr>
+          <p:cNvCxnSpPr/>
+          <p:nvPr/>
+        </p:nvCxnSpPr>
+        <p:spPr>
+          <a:xfrm>
+            <a:off x="191528" y="1224990"/>
+            <a:ext cx="8760941" cy="0"/>
+          </a:xfrm>
+          <a:prstGeom prst="line">
+            <a:avLst/>
+          </a:prstGeom>
+          <a:ln w="38100"/>
+        </p:spPr>
+        <p:style>
+          <a:lnRef idx="1">
+            <a:schemeClr val="accent1"/>
+          </a:lnRef>
+          <a:fillRef idx="0">
+            <a:schemeClr val="accent1"/>
+          </a:fillRef>
+          <a:effectRef idx="0">
+            <a:schemeClr val="accent1"/>
+          </a:effectRef>
+          <a:fontRef idx="minor">
+            <a:schemeClr val="tx1"/>
+          </a:fontRef>
+        </p:style>
+      </p:cxnSp>
+      <p:pic>
+        <p:nvPicPr>
+          <p:cNvPr id="3" name="Picture 2">
+            <a:extLst>
+              <a:ext uri="{FF2B5EF4-FFF2-40B4-BE49-F238E27FC236}">
+                <a16:creationId xmlns:a16="http://schemas.microsoft.com/office/drawing/2014/main" id="{B482BD01-A780-FD09-25E7-811597A2EB01}"/>
+              </a:ext>
+            </a:extLst>
+          </p:cNvPr>
+          <p:cNvPicPr>
+            <a:picLocks noChangeAspect="1"/>
+          </p:cNvPicPr>
+          <p:nvPr/>
+        </p:nvPicPr>
+        <p:blipFill>
+          <a:blip r:embed="rId3"/>
+          <a:srcRect l="5000" r="15479" b="6311"/>
+          <a:stretch>
+            <a:fillRect/>
+          </a:stretch>
+        </p:blipFill>
+        <p:spPr>
+          <a:xfrm>
+            <a:off x="4180345" y="1718628"/>
+            <a:ext cx="4582178" cy="3779013"/>
+          </a:xfrm>
+          <a:prstGeom prst="rect">
+            <a:avLst/>
+          </a:prstGeom>
+        </p:spPr>
+      </p:pic>
+      <p:sp>
+        <p:nvSpPr>
+          <p:cNvPr id="7" name="Content Placeholder 2">
+            <a:extLst>
+              <a:ext uri="{FF2B5EF4-FFF2-40B4-BE49-F238E27FC236}">
+                <a16:creationId xmlns:a16="http://schemas.microsoft.com/office/drawing/2014/main" id="{DE04E411-9D6A-B0DF-258A-EFDD2F66334E}"/>
+              </a:ext>
+            </a:extLst>
+          </p:cNvPr>
+          <p:cNvSpPr txBox="1">
+            <a:spLocks/>
+          </p:cNvSpPr>
+          <p:nvPr/>
+        </p:nvSpPr>
+        <p:spPr>
+          <a:xfrm>
+            <a:off x="457200" y="1718628"/>
+            <a:ext cx="3723145" cy="4049034"/>
+          </a:xfrm>
+          <a:prstGeom prst="rect">
+            <a:avLst/>
+          </a:prstGeom>
+        </p:spPr>
+        <p:txBody>
+          <a:bodyPr vert="horz" lIns="91440" tIns="45720" rIns="91440" bIns="45720" rtlCol="0">
+            <a:normAutofit/>
+          </a:bodyPr>
+          <a:lstStyle>
+            <a:lvl1pPr marL="171450" indent="-171450" algn="l" defTabSz="685800" rtl="0" eaLnBrk="1" latinLnBrk="0" hangingPunct="1">
+              <a:lnSpc>
+                <a:spcPct val="90000"/>
+              </a:lnSpc>
+              <a:spcBef>
+                <a:spcPts val="750"/>
+              </a:spcBef>
+              <a:buFont typeface="Arial" panose="020B0604020202020204" pitchFamily="34" charset="0"/>
+              <a:buChar char="•"/>
+              <a:defRPr sz="2100" b="0" i="0" kern="1200">
+                <a:solidFill>
+                  <a:schemeClr val="tx1"/>
+                </a:solidFill>
+                <a:latin typeface="+mn-lt"/>
+                <a:ea typeface="+mn-ea"/>
+                <a:cs typeface="+mn-cs"/>
+              </a:defRPr>
+            </a:lvl1pPr>
+            <a:lvl2pPr marL="514350" indent="-171450" algn="l" defTabSz="685800" rtl="0" eaLnBrk="1" latinLnBrk="0" hangingPunct="1">
+              <a:lnSpc>
+                <a:spcPct val="90000"/>
+              </a:lnSpc>
+              <a:spcBef>
+                <a:spcPts val="375"/>
+              </a:spcBef>
+              <a:buFont typeface="Arial" panose="020B0604020202020204" pitchFamily="34" charset="0"/>
+              <a:buChar char="•"/>
+              <a:defRPr sz="1800" b="0" i="0" kern="1200">
+                <a:solidFill>
+                  <a:schemeClr val="tx1"/>
+                </a:solidFill>
+                <a:latin typeface="+mn-lt"/>
+                <a:ea typeface="+mn-ea"/>
+                <a:cs typeface="+mn-cs"/>
+              </a:defRPr>
+            </a:lvl2pPr>
+            <a:lvl3pPr marL="857250" indent="-171450" algn="l" defTabSz="685800" rtl="0" eaLnBrk="1" latinLnBrk="0" hangingPunct="1">
+              <a:lnSpc>
+                <a:spcPct val="90000"/>
+              </a:lnSpc>
+              <a:spcBef>
+                <a:spcPts val="375"/>
+              </a:spcBef>
+              <a:buFont typeface="Arial" panose="020B0604020202020204" pitchFamily="34" charset="0"/>
+              <a:buChar char="•"/>
+              <a:defRPr sz="1500" b="0" i="0" kern="1200">
+                <a:solidFill>
+                  <a:schemeClr val="tx1"/>
+                </a:solidFill>
+                <a:latin typeface="+mn-lt"/>
+                <a:ea typeface="+mn-ea"/>
+                <a:cs typeface="+mn-cs"/>
+              </a:defRPr>
+            </a:lvl3pPr>
+            <a:lvl4pPr marL="1200150" indent="-171450" algn="l" defTabSz="685800" rtl="0" eaLnBrk="1" latinLnBrk="0" hangingPunct="1">
+              <a:lnSpc>
+                <a:spcPct val="90000"/>
+              </a:lnSpc>
+              <a:spcBef>
+                <a:spcPts val="375"/>
+              </a:spcBef>
+              <a:buFont typeface="Arial" panose="020B0604020202020204" pitchFamily="34" charset="0"/>
+              <a:buChar char="•"/>
+              <a:defRPr sz="1350" b="0" i="0" kern="1200">
+                <a:solidFill>
+                  <a:schemeClr val="tx1"/>
+                </a:solidFill>
+                <a:latin typeface="+mn-lt"/>
+                <a:ea typeface="+mn-ea"/>
+                <a:cs typeface="+mn-cs"/>
+              </a:defRPr>
+            </a:lvl4pPr>
+            <a:lvl5pPr marL="1543050" indent="-171450" algn="l" defTabSz="685800" rtl="0" eaLnBrk="1" latinLnBrk="0" hangingPunct="1">
+              <a:lnSpc>
+                <a:spcPct val="90000"/>
+              </a:lnSpc>
+              <a:spcBef>
+                <a:spcPts val="375"/>
+              </a:spcBef>
+              <a:buFont typeface="Arial" panose="020B0604020202020204" pitchFamily="34" charset="0"/>
+              <a:buChar char="•"/>
+              <a:defRPr sz="1350" b="0" i="0" kern="1200">
+                <a:solidFill>
+                  <a:schemeClr val="tx1"/>
+                </a:solidFill>
+                <a:latin typeface="+mn-lt"/>
+                <a:ea typeface="+mn-ea"/>
+                <a:cs typeface="+mn-cs"/>
+              </a:defRPr>
+            </a:lvl5pPr>
+            <a:lvl6pPr marL="1885950" indent="-171450" algn="l" defTabSz="685800" rtl="0" eaLnBrk="1" latinLnBrk="0" hangingPunct="1">
+              <a:lnSpc>
+                <a:spcPct val="90000"/>
+              </a:lnSpc>
+              <a:spcBef>
+                <a:spcPts val="375"/>
+              </a:spcBef>
+              <a:buFont typeface="Arial" panose="020B0604020202020204" pitchFamily="34" charset="0"/>
+              <a:buChar char="•"/>
+              <a:defRPr sz="1350" kern="1200">
+                <a:solidFill>
+                  <a:schemeClr val="tx1"/>
+                </a:solidFill>
+                <a:latin typeface="+mn-lt"/>
+                <a:ea typeface="+mn-ea"/>
+                <a:cs typeface="+mn-cs"/>
+              </a:defRPr>
+            </a:lvl6pPr>
+            <a:lvl7pPr marL="2228850" indent="-171450" algn="l" defTabSz="685800" rtl="0" eaLnBrk="1" latinLnBrk="0" hangingPunct="1">
+              <a:lnSpc>
+                <a:spcPct val="90000"/>
+              </a:lnSpc>
+              <a:spcBef>
+                <a:spcPts val="375"/>
+              </a:spcBef>
+              <a:buFont typeface="Arial" panose="020B0604020202020204" pitchFamily="34" charset="0"/>
+              <a:buChar char="•"/>
+              <a:defRPr sz="1350" kern="1200">
+                <a:solidFill>
+                  <a:schemeClr val="tx1"/>
+                </a:solidFill>
+                <a:latin typeface="+mn-lt"/>
+                <a:ea typeface="+mn-ea"/>
+                <a:cs typeface="+mn-cs"/>
+              </a:defRPr>
+            </a:lvl7pPr>
+            <a:lvl8pPr marL="2571750" indent="-171450" algn="l" defTabSz="685800" rtl="0" eaLnBrk="1" latinLnBrk="0" hangingPunct="1">
+              <a:lnSpc>
+                <a:spcPct val="90000"/>
+              </a:lnSpc>
+              <a:spcBef>
+                <a:spcPts val="375"/>
+              </a:spcBef>
+              <a:buFont typeface="Arial" panose="020B0604020202020204" pitchFamily="34" charset="0"/>
+              <a:buChar char="•"/>
+              <a:defRPr sz="1350" kern="1200">
+                <a:solidFill>
+                  <a:schemeClr val="tx1"/>
+                </a:solidFill>
+                <a:latin typeface="+mn-lt"/>
+                <a:ea typeface="+mn-ea"/>
+                <a:cs typeface="+mn-cs"/>
+              </a:defRPr>
+            </a:lvl8pPr>
+            <a:lvl9pPr marL="2914650" indent="-171450" algn="l" defTabSz="685800" rtl="0" eaLnBrk="1" latinLnBrk="0" hangingPunct="1">
+              <a:lnSpc>
+                <a:spcPct val="90000"/>
+              </a:lnSpc>
+              <a:spcBef>
+                <a:spcPts val="375"/>
+              </a:spcBef>
+              <a:buFont typeface="Arial" panose="020B0604020202020204" pitchFamily="34" charset="0"/>
+              <a:buChar char="•"/>
+              <a:defRPr sz="1350" kern="1200">
+                <a:solidFill>
+                  <a:schemeClr val="tx1"/>
+                </a:solidFill>
+                <a:latin typeface="+mn-lt"/>
+                <a:ea typeface="+mn-ea"/>
+                <a:cs typeface="+mn-cs"/>
+              </a:defRPr>
+            </a:lvl9pPr>
+          </a:lstStyle>
+          <a:p>
+            <a:pPr>
+              <a:spcAft>
+                <a:spcPts val="1200"/>
+              </a:spcAft>
+            </a:pPr>
+            <a:r>
+              <a:rPr lang="en-US" sz="3500" dirty="0"/>
+              <a:t>BM has </a:t>
+            </a:r>
+            <a:r>
+              <a:rPr lang="en-US" sz="3500" b="1" dirty="0">
+                <a:solidFill>
+                  <a:schemeClr val="tx2"/>
+                </a:solidFill>
+              </a:rPr>
+              <a:t>elastic</a:t>
+            </a:r>
+            <a:r>
+              <a:rPr lang="en-US" sz="3500" dirty="0"/>
+              <a:t> properties [2]</a:t>
+            </a:r>
+          </a:p>
+          <a:p>
+            <a:r>
+              <a:rPr lang="en-US" sz="3200" dirty="0"/>
+              <a:t>Elasticity is </a:t>
+            </a:r>
+            <a:r>
+              <a:rPr lang="en-US" sz="3200" b="1" dirty="0">
+                <a:solidFill>
+                  <a:schemeClr val="tx2"/>
+                </a:solidFill>
+              </a:rPr>
+              <a:t>non-linear </a:t>
+            </a:r>
+            <a:r>
+              <a:rPr lang="en-US" sz="3200" dirty="0"/>
+              <a:t>[3]</a:t>
+            </a:r>
+          </a:p>
+          <a:p>
+            <a:pPr lvl="1"/>
+            <a:r>
+              <a:rPr lang="en-US" sz="2900" dirty="0"/>
+              <a:t>More deformation requires more force</a:t>
+            </a:r>
+          </a:p>
+          <a:p>
+            <a:endParaRPr lang="en-US" sz="3200" dirty="0"/>
+          </a:p>
+        </p:txBody>
+      </p:sp>
+      <p:sp>
+        <p:nvSpPr>
+          <p:cNvPr id="2" name="TextBox 1">
+            <a:extLst>
+              <a:ext uri="{FF2B5EF4-FFF2-40B4-BE49-F238E27FC236}">
+                <a16:creationId xmlns:a16="http://schemas.microsoft.com/office/drawing/2014/main" id="{1700A5D5-ADBD-8BBD-CB27-F76B67F1F06E}"/>
+              </a:ext>
+            </a:extLst>
+          </p:cNvPr>
+          <p:cNvSpPr txBox="1"/>
+          <p:nvPr/>
+        </p:nvSpPr>
+        <p:spPr>
+          <a:xfrm>
+            <a:off x="2680569" y="5604224"/>
+            <a:ext cx="6425852" cy="1061829"/>
+          </a:xfrm>
+          <a:prstGeom prst="rect">
+            <a:avLst/>
+          </a:prstGeom>
+          <a:noFill/>
+        </p:spPr>
+        <p:txBody>
+          <a:bodyPr wrap="square" rtlCol="0">
+            <a:spAutoFit/>
+          </a:bodyPr>
+          <a:lstStyle/>
+          <a:p>
+            <a:r>
+              <a:rPr lang="en-US" sz="1050" dirty="0">
+                <a:solidFill>
+                  <a:srgbClr val="1B1B1B"/>
+                </a:solidFill>
+                <a:latin typeface="Roboto Mono Web"/>
+              </a:rPr>
+              <a:t>[2] H. Li, Y. Zheng, Y.L. Han, S. Cai, &amp; M. Guo, Nonlinear elasticity of biological basement membrane revealed by rapid inflation and deflation, Proc. Natl. Acad. Sci. U.S.A. 118 (11) e2022422118, https://doi.org/10.1073/pnas.2022422118 (2021).</a:t>
+            </a:r>
+          </a:p>
+          <a:p>
+            <a:endParaRPr lang="en-US" sz="1050" dirty="0">
+              <a:solidFill>
+                <a:srgbClr val="1B1B1B"/>
+              </a:solidFill>
+              <a:latin typeface="Roboto Mono Web"/>
+            </a:endParaRPr>
+          </a:p>
+          <a:p>
+            <a:r>
+              <a:rPr lang="en-US" sz="1050" dirty="0"/>
+              <a:t>[3] Guerra </a:t>
+            </a:r>
+            <a:r>
+              <a:rPr lang="en-US" sz="1050" dirty="0" err="1"/>
+              <a:t>Santillán</a:t>
+            </a:r>
+            <a:r>
+              <a:rPr lang="en-US" sz="1050" dirty="0"/>
+              <a:t> KY, </a:t>
+            </a:r>
+            <a:r>
+              <a:rPr lang="en-US" sz="1050" dirty="0" err="1"/>
+              <a:t>Dahmann</a:t>
+            </a:r>
+            <a:r>
+              <a:rPr lang="en-US" sz="1050" dirty="0"/>
+              <a:t> C, Fischer-Friedrich E. Elastic Contractile Stress in the Basement Membrane Generates Basal Tension in Epithelia. PRX Life. 2024;2(1):013004. doi:10.1103/PRXLife.2.013004</a:t>
+            </a:r>
+            <a:endParaRPr lang="en-US" sz="1050" dirty="0">
+              <a:solidFill>
+                <a:srgbClr val="1B1B1B"/>
+              </a:solidFill>
+              <a:latin typeface="Roboto Mono Web"/>
+            </a:endParaRPr>
+          </a:p>
+        </p:txBody>
+      </p:sp>
+    </p:spTree>
+    <p:extLst>
+      <p:ext uri="{BB962C8B-B14F-4D97-AF65-F5344CB8AC3E}">
+        <p14:creationId xmlns:p14="http://schemas.microsoft.com/office/powerpoint/2010/main" val="2854264471"/>
+      </p:ext>
+    </p:extLst>
+  </p:cSld>
+  <p:clrMapOvr>
+    <a:masterClrMapping/>
+  </p:clrMapOvr>
+</p:sld>
+</file>
+
+<file path=ppt/slides/slide5.xml><?xml version="1.0" encoding="utf-8"?>
+<p:sld xmlns:a="http://schemas.openxmlformats.org/drawingml/2006/main" xmlns:r="http://schemas.openxmlformats.org/officeDocument/2006/relationships" xmlns:p="http://schemas.openxmlformats.org/presentationml/2006/main">
+  <p:cSld>
+    <p:spTree>
+      <p:nvGrpSpPr>
+        <p:cNvPr id="1" name="">
+          <a:extLst>
+            <a:ext uri="{FF2B5EF4-FFF2-40B4-BE49-F238E27FC236}">
+              <a16:creationId xmlns:a16="http://schemas.microsoft.com/office/drawing/2014/main" id="{E275CD3C-FB4F-D50E-1D8C-4845A0BF752E}"/>
+            </a:ext>
+          </a:extLst>
+        </p:cNvPr>
+        <p:cNvGrpSpPr/>
+        <p:nvPr/>
+      </p:nvGrpSpPr>
+      <p:grpSpPr>
+        <a:xfrm>
+          <a:off x="0" y="0"/>
+          <a:ext cx="0" cy="0"/>
+          <a:chOff x="0" y="0"/>
+          <a:chExt cx="0" cy="0"/>
+        </a:xfrm>
+      </p:grpSpPr>
+      <p:sp>
+        <p:nvSpPr>
+          <p:cNvPr id="10" name="Title 9">
+            <a:extLst>
+              <a:ext uri="{FF2B5EF4-FFF2-40B4-BE49-F238E27FC236}">
+                <a16:creationId xmlns:a16="http://schemas.microsoft.com/office/drawing/2014/main" id="{78397271-60E8-4F00-F75D-30C9EB8C286E}"/>
+              </a:ext>
+            </a:extLst>
+          </p:cNvPr>
+          <p:cNvSpPr>
+            <a:spLocks noGrp="1"/>
+          </p:cNvSpPr>
+          <p:nvPr>
+            <p:ph type="title"/>
+          </p:nvPr>
+        </p:nvSpPr>
+        <p:spPr>
+          <a:xfrm>
+            <a:off x="457200" y="331927"/>
+            <a:ext cx="7886700" cy="994172"/>
+          </a:xfrm>
+        </p:spPr>
+        <p:txBody>
+          <a:bodyPr>
+            <a:noAutofit/>
+          </a:bodyPr>
+          <a:lstStyle/>
+          <a:p>
+            <a:r>
+              <a:rPr lang="en-US" sz="3200" b="1" dirty="0">
+                <a:solidFill>
+                  <a:srgbClr val="171C8C"/>
+                </a:solidFill>
+                <a:latin typeface="Arial" panose="020B0604020202020204" pitchFamily="34" charset="0"/>
+                <a:cs typeface="Arial" panose="020B0604020202020204" pitchFamily="34" charset="0"/>
+              </a:rPr>
+              <a:t>Cell-BM Interactions</a:t>
+            </a:r>
+          </a:p>
+        </p:txBody>
+      </p:sp>
+      <p:cxnSp>
+        <p:nvCxnSpPr>
+          <p:cNvPr id="5" name="Straight Connector 4">
+            <a:extLst>
+              <a:ext uri="{FF2B5EF4-FFF2-40B4-BE49-F238E27FC236}">
+                <a16:creationId xmlns:a16="http://schemas.microsoft.com/office/drawing/2014/main" id="{3F925189-EE50-1C99-3C70-A3E828108B15}"/>
+              </a:ext>
+            </a:extLst>
+          </p:cNvPr>
+          <p:cNvCxnSpPr/>
+          <p:nvPr/>
+        </p:nvCxnSpPr>
+        <p:spPr>
+          <a:xfrm>
+            <a:off x="191528" y="1224990"/>
+            <a:ext cx="8760941" cy="0"/>
+          </a:xfrm>
+          <a:prstGeom prst="line">
+            <a:avLst/>
+          </a:prstGeom>
+          <a:ln w="38100"/>
+        </p:spPr>
+        <p:style>
+          <a:lnRef idx="1">
+            <a:schemeClr val="accent1"/>
+          </a:lnRef>
+          <a:fillRef idx="0">
+            <a:schemeClr val="accent1"/>
+          </a:fillRef>
+          <a:effectRef idx="0">
+            <a:schemeClr val="accent1"/>
+          </a:effectRef>
+          <a:fontRef idx="minor">
+            <a:schemeClr val="tx1"/>
+          </a:fontRef>
+        </p:style>
+      </p:cxnSp>
+      <p:pic>
+        <p:nvPicPr>
+          <p:cNvPr id="3" name="Picture 2">
+            <a:extLst>
+              <a:ext uri="{FF2B5EF4-FFF2-40B4-BE49-F238E27FC236}">
+                <a16:creationId xmlns:a16="http://schemas.microsoft.com/office/drawing/2014/main" id="{94EDA49F-D1BE-029B-16F1-9BA124E35420}"/>
+              </a:ext>
+            </a:extLst>
+          </p:cNvPr>
+          <p:cNvPicPr>
+            <a:picLocks noChangeAspect="1"/>
+          </p:cNvPicPr>
+          <p:nvPr/>
+        </p:nvPicPr>
+        <p:blipFill>
+          <a:blip r:embed="rId3"/>
+          <a:srcRect l="5000" r="15479" b="6311"/>
+          <a:stretch>
+            <a:fillRect/>
+          </a:stretch>
+        </p:blipFill>
+        <p:spPr>
+          <a:xfrm>
+            <a:off x="4180345" y="1853997"/>
+            <a:ext cx="4582178" cy="3779013"/>
+          </a:xfrm>
+          <a:prstGeom prst="rect">
+            <a:avLst/>
+          </a:prstGeom>
+        </p:spPr>
+      </p:pic>
+      <mc:AlternateContent xmlns:mc="http://schemas.openxmlformats.org/markup-compatibility/2006">
+        <mc:Choice xmlns:a14="http://schemas.microsoft.com/office/drawing/2010/main" Requires="a14">
+          <p:sp>
+            <p:nvSpPr>
+              <p:cNvPr id="7" name="Content Placeholder 2">
+                <a:extLst>
+                  <a:ext uri="{FF2B5EF4-FFF2-40B4-BE49-F238E27FC236}">
+                    <a16:creationId xmlns:a16="http://schemas.microsoft.com/office/drawing/2014/main" id="{1A4300AF-BF56-E8B5-CFF0-187877E41986}"/>
+                  </a:ext>
+                </a:extLst>
+              </p:cNvPr>
+              <p:cNvSpPr txBox="1">
+                <a:spLocks/>
+              </p:cNvSpPr>
+              <p:nvPr/>
+            </p:nvSpPr>
+            <p:spPr>
+              <a:xfrm>
+                <a:off x="457199" y="1718628"/>
+                <a:ext cx="4582177" cy="3354412"/>
+              </a:xfrm>
+              <a:prstGeom prst="rect">
+                <a:avLst/>
+              </a:prstGeom>
+            </p:spPr>
+            <p:txBody>
+              <a:bodyPr vert="horz" lIns="91440" tIns="45720" rIns="91440" bIns="45720" rtlCol="0">
+                <a:normAutofit/>
+              </a:bodyPr>
+              <a:lstStyle>
+                <a:lvl1pPr marL="171450" indent="-171450" algn="l" defTabSz="685800" rtl="0" eaLnBrk="1" latinLnBrk="0" hangingPunct="1">
+                  <a:lnSpc>
+                    <a:spcPct val="90000"/>
+                  </a:lnSpc>
+                  <a:spcBef>
+                    <a:spcPts val="750"/>
+                  </a:spcBef>
+                  <a:buFont typeface="Arial" panose="020B0604020202020204" pitchFamily="34" charset="0"/>
+                  <a:buChar char="•"/>
+                  <a:defRPr sz="2100" b="0" i="0" kern="1200">
+                    <a:solidFill>
+                      <a:schemeClr val="tx1"/>
+                    </a:solidFill>
+                    <a:latin typeface="+mn-lt"/>
+                    <a:ea typeface="+mn-ea"/>
+                    <a:cs typeface="+mn-cs"/>
+                  </a:defRPr>
+                </a:lvl1pPr>
+                <a:lvl2pPr marL="514350" indent="-171450" algn="l" defTabSz="685800" rtl="0" eaLnBrk="1" latinLnBrk="0" hangingPunct="1">
+                  <a:lnSpc>
+                    <a:spcPct val="90000"/>
+                  </a:lnSpc>
+                  <a:spcBef>
+                    <a:spcPts val="375"/>
+                  </a:spcBef>
+                  <a:buFont typeface="Arial" panose="020B0604020202020204" pitchFamily="34" charset="0"/>
+                  <a:buChar char="•"/>
+                  <a:defRPr sz="1800" b="0" i="0" kern="1200">
+                    <a:solidFill>
+                      <a:schemeClr val="tx1"/>
+                    </a:solidFill>
+                    <a:latin typeface="+mn-lt"/>
+                    <a:ea typeface="+mn-ea"/>
+                    <a:cs typeface="+mn-cs"/>
+                  </a:defRPr>
+                </a:lvl2pPr>
+                <a:lvl3pPr marL="857250" indent="-171450" algn="l" defTabSz="685800" rtl="0" eaLnBrk="1" latinLnBrk="0" hangingPunct="1">
+                  <a:lnSpc>
+                    <a:spcPct val="90000"/>
+                  </a:lnSpc>
+                  <a:spcBef>
+                    <a:spcPts val="375"/>
+                  </a:spcBef>
+                  <a:buFont typeface="Arial" panose="020B0604020202020204" pitchFamily="34" charset="0"/>
+                  <a:buChar char="•"/>
+                  <a:defRPr sz="1500" b="0" i="0" kern="1200">
+                    <a:solidFill>
+                      <a:schemeClr val="tx1"/>
+                    </a:solidFill>
+                    <a:latin typeface="+mn-lt"/>
+                    <a:ea typeface="+mn-ea"/>
+                    <a:cs typeface="+mn-cs"/>
+                  </a:defRPr>
+                </a:lvl3pPr>
+                <a:lvl4pPr marL="1200150" indent="-171450" algn="l" defTabSz="685800" rtl="0" eaLnBrk="1" latinLnBrk="0" hangingPunct="1">
+                  <a:lnSpc>
+                    <a:spcPct val="90000"/>
+                  </a:lnSpc>
+                  <a:spcBef>
+                    <a:spcPts val="375"/>
+                  </a:spcBef>
+                  <a:buFont typeface="Arial" panose="020B0604020202020204" pitchFamily="34" charset="0"/>
+                  <a:buChar char="•"/>
+                  <a:defRPr sz="1350" b="0" i="0" kern="1200">
+                    <a:solidFill>
+                      <a:schemeClr val="tx1"/>
+                    </a:solidFill>
+                    <a:latin typeface="+mn-lt"/>
+                    <a:ea typeface="+mn-ea"/>
+                    <a:cs typeface="+mn-cs"/>
+                  </a:defRPr>
+                </a:lvl4pPr>
+                <a:lvl5pPr marL="1543050" indent="-171450" algn="l" defTabSz="685800" rtl="0" eaLnBrk="1" latinLnBrk="0" hangingPunct="1">
+                  <a:lnSpc>
+                    <a:spcPct val="90000"/>
+                  </a:lnSpc>
+                  <a:spcBef>
+                    <a:spcPts val="375"/>
+                  </a:spcBef>
+                  <a:buFont typeface="Arial" panose="020B0604020202020204" pitchFamily="34" charset="0"/>
+                  <a:buChar char="•"/>
+                  <a:defRPr sz="1350" b="0" i="0" kern="1200">
+                    <a:solidFill>
+                      <a:schemeClr val="tx1"/>
+                    </a:solidFill>
+                    <a:latin typeface="+mn-lt"/>
+                    <a:ea typeface="+mn-ea"/>
+                    <a:cs typeface="+mn-cs"/>
+                  </a:defRPr>
+                </a:lvl5pPr>
+                <a:lvl6pPr marL="1885950" indent="-171450" algn="l" defTabSz="685800" rtl="0" eaLnBrk="1" latinLnBrk="0" hangingPunct="1">
+                  <a:lnSpc>
+                    <a:spcPct val="90000"/>
+                  </a:lnSpc>
+                  <a:spcBef>
+                    <a:spcPts val="375"/>
+                  </a:spcBef>
+                  <a:buFont typeface="Arial" panose="020B0604020202020204" pitchFamily="34" charset="0"/>
+                  <a:buChar char="•"/>
+                  <a:defRPr sz="1350" kern="1200">
+                    <a:solidFill>
+                      <a:schemeClr val="tx1"/>
+                    </a:solidFill>
+                    <a:latin typeface="+mn-lt"/>
+                    <a:ea typeface="+mn-ea"/>
+                    <a:cs typeface="+mn-cs"/>
+                  </a:defRPr>
+                </a:lvl6pPr>
+                <a:lvl7pPr marL="2228850" indent="-171450" algn="l" defTabSz="685800" rtl="0" eaLnBrk="1" latinLnBrk="0" hangingPunct="1">
+                  <a:lnSpc>
+                    <a:spcPct val="90000"/>
+                  </a:lnSpc>
+                  <a:spcBef>
+                    <a:spcPts val="375"/>
+                  </a:spcBef>
+                  <a:buFont typeface="Arial" panose="020B0604020202020204" pitchFamily="34" charset="0"/>
+                  <a:buChar char="•"/>
+                  <a:defRPr sz="1350" kern="1200">
+                    <a:solidFill>
+                      <a:schemeClr val="tx1"/>
+                    </a:solidFill>
+                    <a:latin typeface="+mn-lt"/>
+                    <a:ea typeface="+mn-ea"/>
+                    <a:cs typeface="+mn-cs"/>
+                  </a:defRPr>
+                </a:lvl7pPr>
+                <a:lvl8pPr marL="2571750" indent="-171450" algn="l" defTabSz="685800" rtl="0" eaLnBrk="1" latinLnBrk="0" hangingPunct="1">
+                  <a:lnSpc>
+                    <a:spcPct val="90000"/>
+                  </a:lnSpc>
+                  <a:spcBef>
+                    <a:spcPts val="375"/>
+                  </a:spcBef>
+                  <a:buFont typeface="Arial" panose="020B0604020202020204" pitchFamily="34" charset="0"/>
+                  <a:buChar char="•"/>
+                  <a:defRPr sz="1350" kern="1200">
+                    <a:solidFill>
+                      <a:schemeClr val="tx1"/>
+                    </a:solidFill>
+                    <a:latin typeface="+mn-lt"/>
+                    <a:ea typeface="+mn-ea"/>
+                    <a:cs typeface="+mn-cs"/>
+                  </a:defRPr>
+                </a:lvl8pPr>
+                <a:lvl9pPr marL="2914650" indent="-171450" algn="l" defTabSz="685800" rtl="0" eaLnBrk="1" latinLnBrk="0" hangingPunct="1">
+                  <a:lnSpc>
+                    <a:spcPct val="90000"/>
+                  </a:lnSpc>
+                  <a:spcBef>
+                    <a:spcPts val="375"/>
+                  </a:spcBef>
+                  <a:buFont typeface="Arial" panose="020B0604020202020204" pitchFamily="34" charset="0"/>
+                  <a:buChar char="•"/>
+                  <a:defRPr sz="1350" kern="1200">
+                    <a:solidFill>
+                      <a:schemeClr val="tx1"/>
+                    </a:solidFill>
+                    <a:latin typeface="+mn-lt"/>
+                    <a:ea typeface="+mn-ea"/>
+                    <a:cs typeface="+mn-cs"/>
+                  </a:defRPr>
+                </a:lvl9pPr>
+              </a:lstStyle>
+              <a:p>
+                <a:r>
+                  <a:rPr lang="en-US" sz="3200" dirty="0"/>
+                  <a:t>Proposed equation [3]</a:t>
+                </a:r>
+              </a:p>
+              <a:p>
+                <a:endParaRPr lang="en-US" sz="2600" dirty="0"/>
+              </a:p>
+              <a:p>
+                <a:pPr marL="0" indent="0">
+                  <a:buNone/>
+                </a:pPr>
+                <a14:m>
+                  <m:oMathPara xmlns:m="http://schemas.openxmlformats.org/officeDocument/2006/math">
+                    <m:oMathParaPr>
+                      <m:jc m:val="centerGroup"/>
+                    </m:oMathParaPr>
+                    <m:oMath xmlns:m="http://schemas.openxmlformats.org/officeDocument/2006/math">
+                      <m:r>
+                        <a:rPr lang="en-US" sz="2600" b="0" i="1" smtClean="0">
+                          <a:latin typeface="Cambria Math" panose="02040503050406030204" pitchFamily="18" charset="0"/>
+                        </a:rPr>
+                        <m:t>𝜎</m:t>
+                      </m:r>
+                      <m:r>
+                        <a:rPr lang="en-US" sz="2600" b="0" i="1" smtClean="0">
+                          <a:latin typeface="Cambria Math" panose="02040503050406030204" pitchFamily="18" charset="0"/>
+                        </a:rPr>
+                        <m:t>=</m:t>
+                      </m:r>
+                      <m:r>
+                        <a:rPr lang="en-US" sz="2600" b="0" i="1" smtClean="0">
+                          <a:latin typeface="Cambria Math" panose="02040503050406030204" pitchFamily="18" charset="0"/>
+                        </a:rPr>
+                        <m:t>𝐺</m:t>
+                      </m:r>
+                      <m:d>
+                        <m:dPr>
+                          <m:ctrlPr>
+                            <a:rPr lang="en-US" sz="2600" b="0" i="1" smtClean="0">
+                              <a:latin typeface="Cambria Math" panose="02040503050406030204" pitchFamily="18" charset="0"/>
+                            </a:rPr>
+                          </m:ctrlPr>
+                        </m:dPr>
+                        <m:e>
+                          <m:sSup>
+                            <m:sSupPr>
+                              <m:ctrlPr>
+                                <a:rPr lang="en-US" sz="2600" b="0" i="1" smtClean="0">
+                                  <a:latin typeface="Cambria Math" panose="02040503050406030204" pitchFamily="18" charset="0"/>
+                                </a:rPr>
+                              </m:ctrlPr>
+                            </m:sSupPr>
+                            <m:e>
+                              <m:r>
+                                <a:rPr lang="en-US" sz="2600" b="0" i="1" smtClean="0">
+                                  <a:latin typeface="Cambria Math" panose="02040503050406030204" pitchFamily="18" charset="0"/>
+                                </a:rPr>
+                                <m:t>𝜆</m:t>
+                              </m:r>
+                            </m:e>
+                            <m:sup>
+                              <m:r>
+                                <a:rPr lang="en-US" sz="2600" b="0" i="1" smtClean="0">
+                                  <a:latin typeface="Cambria Math" panose="02040503050406030204" pitchFamily="18" charset="0"/>
+                                </a:rPr>
+                                <m:t>2</m:t>
+                              </m:r>
+                            </m:sup>
+                          </m:sSup>
+                          <m:r>
+                            <a:rPr lang="en-US" sz="2600" b="0" i="1" smtClean="0">
+                              <a:latin typeface="Cambria Math" panose="02040503050406030204" pitchFamily="18" charset="0"/>
+                            </a:rPr>
+                            <m:t>−</m:t>
+                          </m:r>
+                          <m:sSup>
+                            <m:sSupPr>
+                              <m:ctrlPr>
+                                <a:rPr lang="en-US" sz="2600" b="0" i="1" smtClean="0">
+                                  <a:latin typeface="Cambria Math" panose="02040503050406030204" pitchFamily="18" charset="0"/>
+                                </a:rPr>
+                              </m:ctrlPr>
+                            </m:sSupPr>
+                            <m:e>
+                              <m:r>
+                                <a:rPr lang="en-US" sz="2600" b="0" i="1" smtClean="0">
+                                  <a:latin typeface="Cambria Math" panose="02040503050406030204" pitchFamily="18" charset="0"/>
+                                </a:rPr>
+                                <m:t>𝜆</m:t>
+                              </m:r>
+                            </m:e>
+                            <m:sup>
+                              <m:r>
+                                <a:rPr lang="en-US" sz="2600" b="0" i="1" smtClean="0">
+                                  <a:latin typeface="Cambria Math" panose="02040503050406030204" pitchFamily="18" charset="0"/>
+                                </a:rPr>
+                                <m:t>−1</m:t>
+                              </m:r>
+                            </m:sup>
+                          </m:sSup>
+                        </m:e>
+                      </m:d>
+                      <m:sSup>
+                        <m:sSupPr>
+                          <m:ctrlPr>
+                            <a:rPr lang="en-US" sz="2600" b="0" i="1" smtClean="0">
+                              <a:latin typeface="Cambria Math" panose="02040503050406030204" pitchFamily="18" charset="0"/>
+                            </a:rPr>
+                          </m:ctrlPr>
+                        </m:sSupPr>
+                        <m:e>
+                          <m:r>
+                            <a:rPr lang="en-US" sz="2600" b="0" i="1" smtClean="0">
+                              <a:latin typeface="Cambria Math" panose="02040503050406030204" pitchFamily="18" charset="0"/>
+                            </a:rPr>
+                            <m:t>𝑒</m:t>
+                          </m:r>
+                        </m:e>
+                        <m:sup>
+                          <m:r>
+                            <a:rPr lang="en-US" sz="2600" b="0" i="1" smtClean="0">
+                              <a:latin typeface="Cambria Math" panose="02040503050406030204" pitchFamily="18" charset="0"/>
+                            </a:rPr>
+                            <m:t>𝑏</m:t>
+                          </m:r>
+                          <m:d>
+                            <m:dPr>
+                              <m:ctrlPr>
+                                <a:rPr lang="en-US" sz="2600" b="0" i="1" smtClean="0">
+                                  <a:latin typeface="Cambria Math" panose="02040503050406030204" pitchFamily="18" charset="0"/>
+                                </a:rPr>
+                              </m:ctrlPr>
+                            </m:dPr>
+                            <m:e>
+                              <m:sSup>
+                                <m:sSupPr>
+                                  <m:ctrlPr>
+                                    <a:rPr lang="en-US" sz="2600" b="0" i="1" smtClean="0">
+                                      <a:latin typeface="Cambria Math" panose="02040503050406030204" pitchFamily="18" charset="0"/>
+                                    </a:rPr>
+                                  </m:ctrlPr>
+                                </m:sSupPr>
+                                <m:e>
+                                  <m:r>
+                                    <a:rPr lang="en-US" sz="2600" b="0" i="1" smtClean="0">
+                                      <a:latin typeface="Cambria Math" panose="02040503050406030204" pitchFamily="18" charset="0"/>
+                                    </a:rPr>
+                                    <m:t>𝜆</m:t>
+                                  </m:r>
+                                </m:e>
+                                <m:sup>
+                                  <m:r>
+                                    <a:rPr lang="en-US" sz="2600" b="0" i="1" smtClean="0">
+                                      <a:latin typeface="Cambria Math" panose="02040503050406030204" pitchFamily="18" charset="0"/>
+                                    </a:rPr>
+                                    <m:t>2</m:t>
+                                  </m:r>
+                                </m:sup>
+                              </m:sSup>
+                              <m:r>
+                                <a:rPr lang="en-US" sz="2600" b="0" i="1" smtClean="0">
+                                  <a:latin typeface="Cambria Math" panose="02040503050406030204" pitchFamily="18" charset="0"/>
+                                </a:rPr>
+                                <m:t>+2</m:t>
+                              </m:r>
+                              <m:sSup>
+                                <m:sSupPr>
+                                  <m:ctrlPr>
+                                    <a:rPr lang="en-US" sz="2600" b="0" i="1" smtClean="0">
+                                      <a:latin typeface="Cambria Math" panose="02040503050406030204" pitchFamily="18" charset="0"/>
+                                    </a:rPr>
+                                  </m:ctrlPr>
+                                </m:sSupPr>
+                                <m:e>
+                                  <m:r>
+                                    <a:rPr lang="en-US" sz="2600" b="0" i="1" smtClean="0">
+                                      <a:latin typeface="Cambria Math" panose="02040503050406030204" pitchFamily="18" charset="0"/>
+                                    </a:rPr>
+                                    <m:t>𝜆</m:t>
+                                  </m:r>
+                                </m:e>
+                                <m:sup>
+                                  <m:r>
+                                    <a:rPr lang="en-US" sz="2600" b="0" i="1" smtClean="0">
+                                      <a:latin typeface="Cambria Math" panose="02040503050406030204" pitchFamily="18" charset="0"/>
+                                    </a:rPr>
+                                    <m:t>−1</m:t>
+                                  </m:r>
+                                </m:sup>
+                              </m:sSup>
+                              <m:r>
+                                <a:rPr lang="en-US" sz="2600" b="0" i="1" smtClean="0">
+                                  <a:latin typeface="Cambria Math" panose="02040503050406030204" pitchFamily="18" charset="0"/>
+                                </a:rPr>
+                                <m:t>−3</m:t>
+                              </m:r>
+                            </m:e>
+                          </m:d>
+                        </m:sup>
+                      </m:sSup>
+                    </m:oMath>
+                  </m:oMathPara>
+                </a14:m>
+                <a:endParaRPr lang="en-US" sz="2600" dirty="0"/>
+              </a:p>
+              <a:p>
+                <a:pPr marL="0" indent="0">
+                  <a:buNone/>
+                </a:pPr>
+                <a:endParaRPr lang="en-US" sz="2600" dirty="0"/>
+              </a:p>
+              <a:p>
+                <a:pPr marL="0" indent="0">
+                  <a:buNone/>
+                </a:pPr>
+                <a:r>
+                  <a:rPr lang="en-US" sz="2600" dirty="0"/>
+                  <a:t>G - initial stiffness</a:t>
+                </a:r>
+              </a:p>
+              <a:p>
+                <a:pPr marL="0" indent="0">
+                  <a:buNone/>
+                </a:pPr>
+                <a:r>
+                  <a:rPr lang="en-US" sz="2600" dirty="0"/>
+                  <a:t>b - stiffness parameter</a:t>
+                </a:r>
+              </a:p>
+            </p:txBody>
+          </p:sp>
+        </mc:Choice>
+        <mc:Fallback>
+          <p:sp>
+            <p:nvSpPr>
+              <p:cNvPr id="7" name="Content Placeholder 2">
+                <a:extLst>
+                  <a:ext uri="{FF2B5EF4-FFF2-40B4-BE49-F238E27FC236}">
+                    <a16:creationId xmlns:a16="http://schemas.microsoft.com/office/drawing/2014/main" id="{1A4300AF-BF56-E8B5-CFF0-187877E41986}"/>
+                  </a:ext>
+                </a:extLst>
+              </p:cNvPr>
+              <p:cNvSpPr txBox="1">
+                <a:spLocks noRot="1" noChangeAspect="1" noMove="1" noResize="1" noEditPoints="1" noAdjustHandles="1" noChangeArrowheads="1" noChangeShapeType="1" noTextEdit="1"/>
+              </p:cNvSpPr>
+              <p:nvPr/>
+            </p:nvSpPr>
+            <p:spPr>
+              <a:xfrm>
+                <a:off x="457199" y="1718628"/>
+                <a:ext cx="4582177" cy="3354412"/>
+              </a:xfrm>
+              <a:prstGeom prst="rect">
+                <a:avLst/>
+              </a:prstGeom>
+              <a:blipFill>
+                <a:blip r:embed="rId4"/>
+                <a:stretch>
+                  <a:fillRect l="-3059" t="-3818"/>
+                </a:stretch>
+              </a:blipFill>
+            </p:spPr>
+            <p:txBody>
+              <a:bodyPr/>
+              <a:lstStyle/>
+              <a:p>
+                <a:r>
+                  <a:rPr lang="en-US">
+                    <a:noFill/>
+                  </a:rPr>
+                  <a:t> </a:t>
+                </a:r>
+              </a:p>
+            </p:txBody>
+          </p:sp>
+        </mc:Fallback>
+      </mc:AlternateContent>
+      <p:sp>
+        <p:nvSpPr>
+          <p:cNvPr id="4" name="TextBox 3">
+            <a:extLst>
+              <a:ext uri="{FF2B5EF4-FFF2-40B4-BE49-F238E27FC236}">
+                <a16:creationId xmlns:a16="http://schemas.microsoft.com/office/drawing/2014/main" id="{E0E1A0C0-79D0-65B0-D22E-2AB392684E7E}"/>
+              </a:ext>
+            </a:extLst>
+          </p:cNvPr>
+          <p:cNvSpPr txBox="1"/>
+          <p:nvPr/>
+        </p:nvSpPr>
+        <p:spPr>
+          <a:xfrm>
+            <a:off x="2981195" y="5823434"/>
+            <a:ext cx="5874706" cy="877163"/>
+          </a:xfrm>
+          <a:prstGeom prst="rect">
+            <a:avLst/>
+          </a:prstGeom>
+          <a:noFill/>
+        </p:spPr>
+        <p:txBody>
+          <a:bodyPr wrap="square" rtlCol="0">
+            <a:spAutoFit/>
+          </a:bodyPr>
+          <a:lstStyle/>
+          <a:p>
+            <a:r>
+              <a:rPr lang="en-US" sz="1100" dirty="0">
+                <a:solidFill>
+                  <a:srgbClr val="1B1B1B"/>
+                </a:solidFill>
+                <a:latin typeface="Roboto Mono Web"/>
+              </a:rPr>
+              <a:t>[3] H. Li, Y. Zheng, Y.L. Han, S. Cai, &amp; M. Guo, Nonlinear elasticity of biological basement membrane revealed by rapid inflation and deflation, Proc. Natl. Acad. Sci. U.S.A. 118 (11) e2022422118, https://doi.org/10.1073/pnas.2022422118 (2021).</a:t>
+            </a:r>
+          </a:p>
+          <a:p>
+            <a:endParaRPr lang="en-US" dirty="0"/>
+          </a:p>
+        </p:txBody>
+      </p:sp>
+    </p:spTree>
+    <p:extLst>
+      <p:ext uri="{BB962C8B-B14F-4D97-AF65-F5344CB8AC3E}">
+        <p14:creationId xmlns:p14="http://schemas.microsoft.com/office/powerpoint/2010/main" val="3229077264"/>
+      </p:ext>
+    </p:extLst>
+  </p:cSld>
+  <p:clrMapOvr>
+    <a:masterClrMapping/>
+  </p:clrMapOvr>
+</p:sld>
+</file>
+
+<file path=ppt/slides/slide6.xml><?xml version="1.0" encoding="utf-8"?>
+<p:sld xmlns:a="http://schemas.openxmlformats.org/drawingml/2006/main" xmlns:r="http://schemas.openxmlformats.org/officeDocument/2006/relationships" xmlns:p="http://schemas.openxmlformats.org/presentationml/2006/main">
+  <p:cSld>
+    <p:spTree>
+      <p:nvGrpSpPr>
+        <p:cNvPr id="1" name="">
+          <a:extLst>
+            <a:ext uri="{FF2B5EF4-FFF2-40B4-BE49-F238E27FC236}">
+              <a16:creationId xmlns:a16="http://schemas.microsoft.com/office/drawing/2014/main" id="{FECED94E-2E58-C319-9E34-B67D96D68E5D}"/>
+            </a:ext>
+          </a:extLst>
+        </p:cNvPr>
+        <p:cNvGrpSpPr/>
+        <p:nvPr/>
+      </p:nvGrpSpPr>
+      <p:grpSpPr>
+        <a:xfrm>
+          <a:off x="0" y="0"/>
+          <a:ext cx="0" cy="0"/>
+          <a:chOff x="0" y="0"/>
+          <a:chExt cx="0" cy="0"/>
+        </a:xfrm>
+      </p:grpSpPr>
+      <p:sp>
+        <p:nvSpPr>
+          <p:cNvPr id="10" name="Title 9">
+            <a:extLst>
+              <a:ext uri="{FF2B5EF4-FFF2-40B4-BE49-F238E27FC236}">
+                <a16:creationId xmlns:a16="http://schemas.microsoft.com/office/drawing/2014/main" id="{8CE4C788-394B-205E-F88A-725D97CCC54F}"/>
+              </a:ext>
+            </a:extLst>
+          </p:cNvPr>
+          <p:cNvSpPr>
+            <a:spLocks noGrp="1"/>
+          </p:cNvSpPr>
+          <p:nvPr>
+            <p:ph type="title"/>
+          </p:nvPr>
+        </p:nvSpPr>
+        <p:spPr>
+          <a:xfrm>
+            <a:off x="457200" y="331927"/>
+            <a:ext cx="7886700" cy="994172"/>
+          </a:xfrm>
+        </p:spPr>
+        <p:txBody>
+          <a:bodyPr>
+            <a:noAutofit/>
+          </a:bodyPr>
+          <a:lstStyle/>
+          <a:p>
+            <a:r>
+              <a:rPr lang="en-US" sz="3200" b="1" dirty="0">
+                <a:solidFill>
+                  <a:srgbClr val="171C8C"/>
+                </a:solidFill>
+                <a:latin typeface="Arial" panose="020B0604020202020204" pitchFamily="34" charset="0"/>
+                <a:cs typeface="Arial" panose="020B0604020202020204" pitchFamily="34" charset="0"/>
+              </a:rPr>
+              <a:t>Repulsive Force</a:t>
+            </a:r>
+          </a:p>
+        </p:txBody>
+      </p:sp>
+      <p:cxnSp>
+        <p:nvCxnSpPr>
+          <p:cNvPr id="5" name="Straight Connector 4">
+            <a:extLst>
+              <a:ext uri="{FF2B5EF4-FFF2-40B4-BE49-F238E27FC236}">
+                <a16:creationId xmlns:a16="http://schemas.microsoft.com/office/drawing/2014/main" id="{24BC1CA8-DBCE-F914-4917-D924A89B9F96}"/>
+              </a:ext>
+            </a:extLst>
+          </p:cNvPr>
+          <p:cNvCxnSpPr/>
+          <p:nvPr/>
+        </p:nvCxnSpPr>
+        <p:spPr>
+          <a:xfrm>
+            <a:off x="191528" y="1224990"/>
+            <a:ext cx="8760941" cy="0"/>
+          </a:xfrm>
+          <a:prstGeom prst="line">
+            <a:avLst/>
+          </a:prstGeom>
+          <a:ln w="38100"/>
+        </p:spPr>
+        <p:style>
+          <a:lnRef idx="1">
+            <a:schemeClr val="accent1"/>
+          </a:lnRef>
+          <a:fillRef idx="0">
+            <a:schemeClr val="accent1"/>
+          </a:fillRef>
+          <a:effectRef idx="0">
+            <a:schemeClr val="accent1"/>
+          </a:effectRef>
+          <a:fontRef idx="minor">
+            <a:schemeClr val="tx1"/>
+          </a:fontRef>
+        </p:style>
+      </p:cxnSp>
+      <p:pic>
+        <p:nvPicPr>
+          <p:cNvPr id="2" name="Picture 1">
+            <a:extLst>
+              <a:ext uri="{FF2B5EF4-FFF2-40B4-BE49-F238E27FC236}">
+                <a16:creationId xmlns:a16="http://schemas.microsoft.com/office/drawing/2014/main" id="{348D79D2-48BF-4A30-AF82-F0A233494F31}"/>
+              </a:ext>
+            </a:extLst>
+          </p:cNvPr>
+          <p:cNvPicPr>
+            <a:picLocks noChangeAspect="1"/>
+          </p:cNvPicPr>
+          <p:nvPr/>
+        </p:nvPicPr>
+        <p:blipFill>
+          <a:blip r:embed="rId3"/>
+          <a:srcRect l="19179" b="6341"/>
+          <a:stretch>
+            <a:fillRect/>
+          </a:stretch>
+        </p:blipFill>
+        <p:spPr>
+          <a:xfrm>
+            <a:off x="4333893" y="2118054"/>
+            <a:ext cx="4618576" cy="3746491"/>
+          </a:xfrm>
+          <a:prstGeom prst="rect">
+            <a:avLst/>
+          </a:prstGeom>
+        </p:spPr>
+      </p:pic>
+      <p:sp>
+        <p:nvSpPr>
+          <p:cNvPr id="3" name="Content Placeholder 2">
+            <a:extLst>
+              <a:ext uri="{FF2B5EF4-FFF2-40B4-BE49-F238E27FC236}">
+                <a16:creationId xmlns:a16="http://schemas.microsoft.com/office/drawing/2014/main" id="{FA85885A-AD1C-108F-5F14-0EF3EB559ABA}"/>
+              </a:ext>
+            </a:extLst>
+          </p:cNvPr>
+          <p:cNvSpPr txBox="1">
+            <a:spLocks/>
+          </p:cNvSpPr>
+          <p:nvPr/>
+        </p:nvSpPr>
+        <p:spPr>
+          <a:xfrm>
+            <a:off x="457199" y="1788090"/>
+            <a:ext cx="3723145" cy="3844911"/>
+          </a:xfrm>
+          <a:prstGeom prst="rect">
+            <a:avLst/>
+          </a:prstGeom>
+        </p:spPr>
+        <p:txBody>
+          <a:bodyPr vert="horz" lIns="91440" tIns="45720" rIns="91440" bIns="45720" rtlCol="0">
+            <a:normAutofit/>
+          </a:bodyPr>
+          <a:lstStyle>
+            <a:lvl1pPr marL="171450" indent="-171450" algn="l" defTabSz="685800" rtl="0" eaLnBrk="1" latinLnBrk="0" hangingPunct="1">
+              <a:lnSpc>
+                <a:spcPct val="90000"/>
+              </a:lnSpc>
+              <a:spcBef>
+                <a:spcPts val="750"/>
+              </a:spcBef>
+              <a:buFont typeface="Arial" panose="020B0604020202020204" pitchFamily="34" charset="0"/>
+              <a:buChar char="•"/>
+              <a:defRPr sz="2100" b="0" i="0" kern="1200">
+                <a:solidFill>
+                  <a:schemeClr val="tx1"/>
+                </a:solidFill>
+                <a:latin typeface="+mn-lt"/>
+                <a:ea typeface="+mn-ea"/>
+                <a:cs typeface="+mn-cs"/>
+              </a:defRPr>
+            </a:lvl1pPr>
+            <a:lvl2pPr marL="514350" indent="-171450" algn="l" defTabSz="685800" rtl="0" eaLnBrk="1" latinLnBrk="0" hangingPunct="1">
+              <a:lnSpc>
+                <a:spcPct val="90000"/>
+              </a:lnSpc>
+              <a:spcBef>
+                <a:spcPts val="375"/>
+              </a:spcBef>
+              <a:buFont typeface="Arial" panose="020B0604020202020204" pitchFamily="34" charset="0"/>
+              <a:buChar char="•"/>
+              <a:defRPr sz="1800" b="0" i="0" kern="1200">
+                <a:solidFill>
+                  <a:schemeClr val="tx1"/>
+                </a:solidFill>
+                <a:latin typeface="+mn-lt"/>
+                <a:ea typeface="+mn-ea"/>
+                <a:cs typeface="+mn-cs"/>
+              </a:defRPr>
+            </a:lvl2pPr>
+            <a:lvl3pPr marL="857250" indent="-171450" algn="l" defTabSz="685800" rtl="0" eaLnBrk="1" latinLnBrk="0" hangingPunct="1">
+              <a:lnSpc>
+                <a:spcPct val="90000"/>
+              </a:lnSpc>
+              <a:spcBef>
+                <a:spcPts val="375"/>
+              </a:spcBef>
+              <a:buFont typeface="Arial" panose="020B0604020202020204" pitchFamily="34" charset="0"/>
+              <a:buChar char="•"/>
+              <a:defRPr sz="1500" b="0" i="0" kern="1200">
+                <a:solidFill>
+                  <a:schemeClr val="tx1"/>
+                </a:solidFill>
+                <a:latin typeface="+mn-lt"/>
+                <a:ea typeface="+mn-ea"/>
+                <a:cs typeface="+mn-cs"/>
+              </a:defRPr>
+            </a:lvl3pPr>
+            <a:lvl4pPr marL="1200150" indent="-171450" algn="l" defTabSz="685800" rtl="0" eaLnBrk="1" latinLnBrk="0" hangingPunct="1">
+              <a:lnSpc>
+                <a:spcPct val="90000"/>
+              </a:lnSpc>
+              <a:spcBef>
+                <a:spcPts val="375"/>
+              </a:spcBef>
+              <a:buFont typeface="Arial" panose="020B0604020202020204" pitchFamily="34" charset="0"/>
+              <a:buChar char="•"/>
+              <a:defRPr sz="1350" b="0" i="0" kern="1200">
+                <a:solidFill>
+                  <a:schemeClr val="tx1"/>
+                </a:solidFill>
+                <a:latin typeface="+mn-lt"/>
+                <a:ea typeface="+mn-ea"/>
+                <a:cs typeface="+mn-cs"/>
+              </a:defRPr>
+            </a:lvl4pPr>
+            <a:lvl5pPr marL="1543050" indent="-171450" algn="l" defTabSz="685800" rtl="0" eaLnBrk="1" latinLnBrk="0" hangingPunct="1">
+              <a:lnSpc>
+                <a:spcPct val="90000"/>
+              </a:lnSpc>
+              <a:spcBef>
+                <a:spcPts val="375"/>
+              </a:spcBef>
+              <a:buFont typeface="Arial" panose="020B0604020202020204" pitchFamily="34" charset="0"/>
+              <a:buChar char="•"/>
+              <a:defRPr sz="1350" b="0" i="0" kern="1200">
+                <a:solidFill>
+                  <a:schemeClr val="tx1"/>
+                </a:solidFill>
+                <a:latin typeface="+mn-lt"/>
+                <a:ea typeface="+mn-ea"/>
+                <a:cs typeface="+mn-cs"/>
+              </a:defRPr>
+            </a:lvl5pPr>
+            <a:lvl6pPr marL="1885950" indent="-171450" algn="l" defTabSz="685800" rtl="0" eaLnBrk="1" latinLnBrk="0" hangingPunct="1">
+              <a:lnSpc>
+                <a:spcPct val="90000"/>
+              </a:lnSpc>
+              <a:spcBef>
+                <a:spcPts val="375"/>
+              </a:spcBef>
+              <a:buFont typeface="Arial" panose="020B0604020202020204" pitchFamily="34" charset="0"/>
+              <a:buChar char="•"/>
+              <a:defRPr sz="1350" kern="1200">
+                <a:solidFill>
+                  <a:schemeClr val="tx1"/>
+                </a:solidFill>
+                <a:latin typeface="+mn-lt"/>
+                <a:ea typeface="+mn-ea"/>
+                <a:cs typeface="+mn-cs"/>
+              </a:defRPr>
+            </a:lvl6pPr>
+            <a:lvl7pPr marL="2228850" indent="-171450" algn="l" defTabSz="685800" rtl="0" eaLnBrk="1" latinLnBrk="0" hangingPunct="1">
+              <a:lnSpc>
+                <a:spcPct val="90000"/>
+              </a:lnSpc>
+              <a:spcBef>
+                <a:spcPts val="375"/>
+              </a:spcBef>
+              <a:buFont typeface="Arial" panose="020B0604020202020204" pitchFamily="34" charset="0"/>
+              <a:buChar char="•"/>
+              <a:defRPr sz="1350" kern="1200">
+                <a:solidFill>
+                  <a:schemeClr val="tx1"/>
+                </a:solidFill>
+                <a:latin typeface="+mn-lt"/>
+                <a:ea typeface="+mn-ea"/>
+                <a:cs typeface="+mn-cs"/>
+              </a:defRPr>
+            </a:lvl7pPr>
+            <a:lvl8pPr marL="2571750" indent="-171450" algn="l" defTabSz="685800" rtl="0" eaLnBrk="1" latinLnBrk="0" hangingPunct="1">
+              <a:lnSpc>
+                <a:spcPct val="90000"/>
+              </a:lnSpc>
+              <a:spcBef>
+                <a:spcPts val="375"/>
+              </a:spcBef>
+              <a:buFont typeface="Arial" panose="020B0604020202020204" pitchFamily="34" charset="0"/>
+              <a:buChar char="•"/>
+              <a:defRPr sz="1350" kern="1200">
+                <a:solidFill>
+                  <a:schemeClr val="tx1"/>
+                </a:solidFill>
+                <a:latin typeface="+mn-lt"/>
+                <a:ea typeface="+mn-ea"/>
+                <a:cs typeface="+mn-cs"/>
+              </a:defRPr>
+            </a:lvl8pPr>
+            <a:lvl9pPr marL="2914650" indent="-171450" algn="l" defTabSz="685800" rtl="0" eaLnBrk="1" latinLnBrk="0" hangingPunct="1">
+              <a:lnSpc>
+                <a:spcPct val="90000"/>
+              </a:lnSpc>
+              <a:spcBef>
+                <a:spcPts val="375"/>
+              </a:spcBef>
+              <a:buFont typeface="Arial" panose="020B0604020202020204" pitchFamily="34" charset="0"/>
+              <a:buChar char="•"/>
+              <a:defRPr sz="1350" kern="1200">
+                <a:solidFill>
+                  <a:schemeClr val="tx1"/>
+                </a:solidFill>
+                <a:latin typeface="+mn-lt"/>
+                <a:ea typeface="+mn-ea"/>
+                <a:cs typeface="+mn-cs"/>
+              </a:defRPr>
+            </a:lvl9pPr>
+          </a:lstStyle>
+          <a:p>
+            <a:pPr>
+              <a:spcAft>
+                <a:spcPts val="1200"/>
+              </a:spcAft>
+            </a:pPr>
+            <a:r>
+              <a:rPr lang="en-US" sz="3500" dirty="0"/>
+              <a:t>BM serves as a </a:t>
+            </a:r>
+            <a:r>
+              <a:rPr lang="en-US" sz="3500" b="1" dirty="0">
+                <a:solidFill>
+                  <a:schemeClr val="tx2"/>
+                </a:solidFill>
+              </a:rPr>
+              <a:t>physical barrier</a:t>
+            </a:r>
+          </a:p>
+          <a:p>
+            <a:r>
+              <a:rPr lang="en-US" sz="3500" dirty="0"/>
+              <a:t>Rupturing of membrane needs to be refined</a:t>
+            </a:r>
+          </a:p>
+          <a:p>
+            <a:endParaRPr lang="en-US" sz="3200" dirty="0"/>
+          </a:p>
+        </p:txBody>
+      </p:sp>
+    </p:spTree>
+    <p:extLst>
+      <p:ext uri="{BB962C8B-B14F-4D97-AF65-F5344CB8AC3E}">
+        <p14:creationId xmlns:p14="http://schemas.microsoft.com/office/powerpoint/2010/main" val="3606467243"/>
+      </p:ext>
+    </p:extLst>
+  </p:cSld>
+  <p:clrMapOvr>
+    <a:masterClrMapping/>
+  </p:clrMapOvr>
+</p:sld>
+</file>
+
+<file path=ppt/slides/slide7.xml><?xml version="1.0" encoding="utf-8"?>
+<p:sld xmlns:a="http://schemas.openxmlformats.org/drawingml/2006/main" xmlns:r="http://schemas.openxmlformats.org/officeDocument/2006/relationships" xmlns:p="http://schemas.openxmlformats.org/presentationml/2006/main">
+  <p:cSld>
+    <p:spTree>
+      <p:nvGrpSpPr>
+        <p:cNvPr id="1" name="">
+          <a:extLst>
+            <a:ext uri="{FF2B5EF4-FFF2-40B4-BE49-F238E27FC236}">
+              <a16:creationId xmlns:a16="http://schemas.microsoft.com/office/drawing/2014/main" id="{AE9FDA79-EB81-1AE8-53C7-4C82E7DA4F64}"/>
+            </a:ext>
+          </a:extLst>
+        </p:cNvPr>
+        <p:cNvGrpSpPr/>
+        <p:nvPr/>
+      </p:nvGrpSpPr>
+      <p:grpSpPr>
+        <a:xfrm>
+          <a:off x="0" y="0"/>
+          <a:ext cx="0" cy="0"/>
+          <a:chOff x="0" y="0"/>
+          <a:chExt cx="0" cy="0"/>
+        </a:xfrm>
+      </p:grpSpPr>
+      <p:sp>
+        <p:nvSpPr>
+          <p:cNvPr id="10" name="Title 9">
+            <a:extLst>
+              <a:ext uri="{FF2B5EF4-FFF2-40B4-BE49-F238E27FC236}">
+                <a16:creationId xmlns:a16="http://schemas.microsoft.com/office/drawing/2014/main" id="{830FDC25-5EDB-BD22-8DC7-07CF81E2E720}"/>
+              </a:ext>
+            </a:extLst>
+          </p:cNvPr>
+          <p:cNvSpPr>
+            <a:spLocks noGrp="1"/>
+          </p:cNvSpPr>
+          <p:nvPr>
+            <p:ph type="title"/>
+          </p:nvPr>
+        </p:nvSpPr>
+        <p:spPr>
+          <a:xfrm>
+            <a:off x="457200" y="331927"/>
+            <a:ext cx="7886700" cy="994172"/>
+          </a:xfrm>
+        </p:spPr>
+        <p:txBody>
+          <a:bodyPr>
+            <a:noAutofit/>
+          </a:bodyPr>
+          <a:lstStyle/>
+          <a:p>
+            <a:r>
+              <a:rPr lang="en-US" sz="3200" b="1" dirty="0">
+                <a:solidFill>
+                  <a:srgbClr val="171C8C"/>
+                </a:solidFill>
+                <a:latin typeface="Arial" panose="020B0604020202020204" pitchFamily="34" charset="0"/>
+                <a:cs typeface="Arial" panose="020B0604020202020204" pitchFamily="34" charset="0"/>
+              </a:rPr>
+              <a:t>Fibroblasts Interactions</a:t>
+            </a:r>
+          </a:p>
+        </p:txBody>
+      </p:sp>
+      <p:cxnSp>
+        <p:nvCxnSpPr>
+          <p:cNvPr id="5" name="Straight Connector 4">
+            <a:extLst>
+              <a:ext uri="{FF2B5EF4-FFF2-40B4-BE49-F238E27FC236}">
+                <a16:creationId xmlns:a16="http://schemas.microsoft.com/office/drawing/2014/main" id="{A4EA32A1-3FB2-5B01-D438-64EBF5F45EAA}"/>
+              </a:ext>
+            </a:extLst>
+          </p:cNvPr>
+          <p:cNvCxnSpPr/>
+          <p:nvPr/>
+        </p:nvCxnSpPr>
+        <p:spPr>
+          <a:xfrm>
+            <a:off x="191528" y="1224990"/>
+            <a:ext cx="8760941" cy="0"/>
+          </a:xfrm>
+          <a:prstGeom prst="line">
+            <a:avLst/>
+          </a:prstGeom>
+          <a:ln w="38100"/>
+        </p:spPr>
+        <p:style>
+          <a:lnRef idx="1">
+            <a:schemeClr val="accent1"/>
+          </a:lnRef>
+          <a:fillRef idx="0">
+            <a:schemeClr val="accent1"/>
+          </a:fillRef>
+          <a:effectRef idx="0">
+            <a:schemeClr val="accent1"/>
+          </a:effectRef>
+          <a:fontRef idx="minor">
+            <a:schemeClr val="tx1"/>
+          </a:fontRef>
+        </p:style>
+      </p:cxnSp>
+      <p:pic>
+        <p:nvPicPr>
+          <p:cNvPr id="2" name="Picture 1">
+            <a:extLst>
+              <a:ext uri="{FF2B5EF4-FFF2-40B4-BE49-F238E27FC236}">
+                <a16:creationId xmlns:a16="http://schemas.microsoft.com/office/drawing/2014/main" id="{90BE2CBB-BD84-F35D-55A5-4C003BD8C36F}"/>
+              </a:ext>
+            </a:extLst>
+          </p:cNvPr>
+          <p:cNvPicPr>
+            <a:picLocks noChangeAspect="1"/>
+          </p:cNvPicPr>
+          <p:nvPr/>
+        </p:nvPicPr>
+        <p:blipFill>
+          <a:blip r:embed="rId3"/>
+          <a:srcRect l="19179" b="6341"/>
+          <a:stretch>
+            <a:fillRect/>
+          </a:stretch>
+        </p:blipFill>
+        <p:spPr>
+          <a:xfrm>
+            <a:off x="4333893" y="2118054"/>
+            <a:ext cx="4618576" cy="3746491"/>
+          </a:xfrm>
+          <a:prstGeom prst="rect">
+            <a:avLst/>
+          </a:prstGeom>
+        </p:spPr>
+      </p:pic>
+      <p:sp>
+        <p:nvSpPr>
+          <p:cNvPr id="3" name="Content Placeholder 2">
+            <a:extLst>
+              <a:ext uri="{FF2B5EF4-FFF2-40B4-BE49-F238E27FC236}">
+                <a16:creationId xmlns:a16="http://schemas.microsoft.com/office/drawing/2014/main" id="{6A08628D-79D5-4A66-D6A5-6FDFFD549388}"/>
+              </a:ext>
+            </a:extLst>
+          </p:cNvPr>
+          <p:cNvSpPr txBox="1">
+            <a:spLocks/>
+          </p:cNvSpPr>
+          <p:nvPr/>
+        </p:nvSpPr>
+        <p:spPr>
+          <a:xfrm>
+            <a:off x="457199" y="1788090"/>
+            <a:ext cx="3723145" cy="3844911"/>
+          </a:xfrm>
+          <a:prstGeom prst="rect">
+            <a:avLst/>
+          </a:prstGeom>
+        </p:spPr>
+        <p:txBody>
+          <a:bodyPr vert="horz" lIns="91440" tIns="45720" rIns="91440" bIns="45720" rtlCol="0">
+            <a:normAutofit/>
+          </a:bodyPr>
+          <a:lstStyle>
+            <a:lvl1pPr marL="171450" indent="-171450" algn="l" defTabSz="685800" rtl="0" eaLnBrk="1" latinLnBrk="0" hangingPunct="1">
+              <a:lnSpc>
+                <a:spcPct val="90000"/>
+              </a:lnSpc>
+              <a:spcBef>
+                <a:spcPts val="750"/>
+              </a:spcBef>
+              <a:buFont typeface="Arial" panose="020B0604020202020204" pitchFamily="34" charset="0"/>
+              <a:buChar char="•"/>
+              <a:defRPr sz="2100" b="0" i="0" kern="1200">
+                <a:solidFill>
+                  <a:schemeClr val="tx1"/>
+                </a:solidFill>
+                <a:latin typeface="+mn-lt"/>
+                <a:ea typeface="+mn-ea"/>
+                <a:cs typeface="+mn-cs"/>
+              </a:defRPr>
+            </a:lvl1pPr>
+            <a:lvl2pPr marL="514350" indent="-171450" algn="l" defTabSz="685800" rtl="0" eaLnBrk="1" latinLnBrk="0" hangingPunct="1">
+              <a:lnSpc>
+                <a:spcPct val="90000"/>
+              </a:lnSpc>
+              <a:spcBef>
+                <a:spcPts val="375"/>
+              </a:spcBef>
+              <a:buFont typeface="Arial" panose="020B0604020202020204" pitchFamily="34" charset="0"/>
+              <a:buChar char="•"/>
+              <a:defRPr sz="1800" b="0" i="0" kern="1200">
+                <a:solidFill>
+                  <a:schemeClr val="tx1"/>
+                </a:solidFill>
+                <a:latin typeface="+mn-lt"/>
+                <a:ea typeface="+mn-ea"/>
+                <a:cs typeface="+mn-cs"/>
+              </a:defRPr>
+            </a:lvl2pPr>
+            <a:lvl3pPr marL="857250" indent="-171450" algn="l" defTabSz="685800" rtl="0" eaLnBrk="1" latinLnBrk="0" hangingPunct="1">
+              <a:lnSpc>
+                <a:spcPct val="90000"/>
+              </a:lnSpc>
+              <a:spcBef>
+                <a:spcPts val="375"/>
+              </a:spcBef>
+              <a:buFont typeface="Arial" panose="020B0604020202020204" pitchFamily="34" charset="0"/>
+              <a:buChar char="•"/>
+              <a:defRPr sz="1500" b="0" i="0" kern="1200">
+                <a:solidFill>
+                  <a:schemeClr val="tx1"/>
+                </a:solidFill>
+                <a:latin typeface="+mn-lt"/>
+                <a:ea typeface="+mn-ea"/>
+                <a:cs typeface="+mn-cs"/>
+              </a:defRPr>
+            </a:lvl3pPr>
+            <a:lvl4pPr marL="1200150" indent="-171450" algn="l" defTabSz="685800" rtl="0" eaLnBrk="1" latinLnBrk="0" hangingPunct="1">
+              <a:lnSpc>
+                <a:spcPct val="90000"/>
+              </a:lnSpc>
+              <a:spcBef>
+                <a:spcPts val="375"/>
+              </a:spcBef>
+              <a:buFont typeface="Arial" panose="020B0604020202020204" pitchFamily="34" charset="0"/>
+              <a:buChar char="•"/>
+              <a:defRPr sz="1350" b="0" i="0" kern="1200">
+                <a:solidFill>
+                  <a:schemeClr val="tx1"/>
+                </a:solidFill>
+                <a:latin typeface="+mn-lt"/>
+                <a:ea typeface="+mn-ea"/>
+                <a:cs typeface="+mn-cs"/>
+              </a:defRPr>
+            </a:lvl4pPr>
+            <a:lvl5pPr marL="1543050" indent="-171450" algn="l" defTabSz="685800" rtl="0" eaLnBrk="1" latinLnBrk="0" hangingPunct="1">
+              <a:lnSpc>
+                <a:spcPct val="90000"/>
+              </a:lnSpc>
+              <a:spcBef>
+                <a:spcPts val="375"/>
+              </a:spcBef>
+              <a:buFont typeface="Arial" panose="020B0604020202020204" pitchFamily="34" charset="0"/>
+              <a:buChar char="•"/>
+              <a:defRPr sz="1350" b="0" i="0" kern="1200">
+                <a:solidFill>
+                  <a:schemeClr val="tx1"/>
+                </a:solidFill>
+                <a:latin typeface="+mn-lt"/>
+                <a:ea typeface="+mn-ea"/>
+                <a:cs typeface="+mn-cs"/>
+              </a:defRPr>
+            </a:lvl5pPr>
+            <a:lvl6pPr marL="1885950" indent="-171450" algn="l" defTabSz="685800" rtl="0" eaLnBrk="1" latinLnBrk="0" hangingPunct="1">
+              <a:lnSpc>
+                <a:spcPct val="90000"/>
+              </a:lnSpc>
+              <a:spcBef>
+                <a:spcPts val="375"/>
+              </a:spcBef>
+              <a:buFont typeface="Arial" panose="020B0604020202020204" pitchFamily="34" charset="0"/>
+              <a:buChar char="•"/>
+              <a:defRPr sz="1350" kern="1200">
+                <a:solidFill>
+                  <a:schemeClr val="tx1"/>
+                </a:solidFill>
+                <a:latin typeface="+mn-lt"/>
+                <a:ea typeface="+mn-ea"/>
+                <a:cs typeface="+mn-cs"/>
+              </a:defRPr>
+            </a:lvl6pPr>
+            <a:lvl7pPr marL="2228850" indent="-171450" algn="l" defTabSz="685800" rtl="0" eaLnBrk="1" latinLnBrk="0" hangingPunct="1">
+              <a:lnSpc>
+                <a:spcPct val="90000"/>
+              </a:lnSpc>
+              <a:spcBef>
+                <a:spcPts val="375"/>
+              </a:spcBef>
+              <a:buFont typeface="Arial" panose="020B0604020202020204" pitchFamily="34" charset="0"/>
+              <a:buChar char="•"/>
+              <a:defRPr sz="1350" kern="1200">
+                <a:solidFill>
+                  <a:schemeClr val="tx1"/>
+                </a:solidFill>
+                <a:latin typeface="+mn-lt"/>
+                <a:ea typeface="+mn-ea"/>
+                <a:cs typeface="+mn-cs"/>
+              </a:defRPr>
+            </a:lvl7pPr>
+            <a:lvl8pPr marL="2571750" indent="-171450" algn="l" defTabSz="685800" rtl="0" eaLnBrk="1" latinLnBrk="0" hangingPunct="1">
+              <a:lnSpc>
+                <a:spcPct val="90000"/>
+              </a:lnSpc>
+              <a:spcBef>
+                <a:spcPts val="375"/>
+              </a:spcBef>
+              <a:buFont typeface="Arial" panose="020B0604020202020204" pitchFamily="34" charset="0"/>
+              <a:buChar char="•"/>
+              <a:defRPr sz="1350" kern="1200">
+                <a:solidFill>
+                  <a:schemeClr val="tx1"/>
+                </a:solidFill>
+                <a:latin typeface="+mn-lt"/>
+                <a:ea typeface="+mn-ea"/>
+                <a:cs typeface="+mn-cs"/>
+              </a:defRPr>
+            </a:lvl8pPr>
+            <a:lvl9pPr marL="2914650" indent="-171450" algn="l" defTabSz="685800" rtl="0" eaLnBrk="1" latinLnBrk="0" hangingPunct="1">
+              <a:lnSpc>
+                <a:spcPct val="90000"/>
+              </a:lnSpc>
+              <a:spcBef>
+                <a:spcPts val="375"/>
+              </a:spcBef>
+              <a:buFont typeface="Arial" panose="020B0604020202020204" pitchFamily="34" charset="0"/>
+              <a:buChar char="•"/>
+              <a:defRPr sz="1350" kern="1200">
+                <a:solidFill>
+                  <a:schemeClr val="tx1"/>
+                </a:solidFill>
+                <a:latin typeface="+mn-lt"/>
+                <a:ea typeface="+mn-ea"/>
+                <a:cs typeface="+mn-cs"/>
+              </a:defRPr>
+            </a:lvl9pPr>
+          </a:lstStyle>
+          <a:p>
+            <a:pPr>
+              <a:spcAft>
+                <a:spcPts val="1200"/>
+              </a:spcAft>
+            </a:pPr>
+            <a:r>
+              <a:rPr lang="en-US" sz="3500" dirty="0"/>
+              <a:t>BM can be effect by </a:t>
+            </a:r>
+            <a:r>
+              <a:rPr lang="en-US" sz="3500" b="1" dirty="0">
+                <a:solidFill>
+                  <a:schemeClr val="tx2"/>
+                </a:solidFill>
+              </a:rPr>
+              <a:t>CAFs </a:t>
+            </a:r>
+            <a:r>
+              <a:rPr lang="en-US" sz="3500" dirty="0"/>
+              <a:t>(Cancer associated fibroblasts)</a:t>
+            </a:r>
+          </a:p>
+          <a:p>
+            <a:r>
+              <a:rPr lang="en-US" sz="3500" dirty="0"/>
+              <a:t>Secreted enzymes </a:t>
+            </a:r>
+            <a:r>
+              <a:rPr lang="en-US" sz="3500" b="1" dirty="0">
+                <a:solidFill>
+                  <a:schemeClr val="tx2"/>
+                </a:solidFill>
+              </a:rPr>
+              <a:t>weaken</a:t>
+            </a:r>
+            <a:r>
+              <a:rPr lang="en-US" sz="3500" dirty="0"/>
+              <a:t> BM</a:t>
+            </a:r>
+          </a:p>
+          <a:p>
+            <a:endParaRPr lang="en-US" sz="3200" dirty="0"/>
+          </a:p>
+        </p:txBody>
+      </p:sp>
+      <p:sp>
+        <p:nvSpPr>
+          <p:cNvPr id="4" name="TextBox 3">
+            <a:extLst>
+              <a:ext uri="{FF2B5EF4-FFF2-40B4-BE49-F238E27FC236}">
+                <a16:creationId xmlns:a16="http://schemas.microsoft.com/office/drawing/2014/main" id="{11C4DDFD-490F-A4C2-5A01-688D47A33A6C}"/>
+              </a:ext>
+            </a:extLst>
+          </p:cNvPr>
+          <p:cNvSpPr txBox="1"/>
+          <p:nvPr/>
+        </p:nvSpPr>
+        <p:spPr>
+          <a:xfrm>
+            <a:off x="2949203" y="5980837"/>
+            <a:ext cx="6003266" cy="877163"/>
+          </a:xfrm>
+          <a:prstGeom prst="rect">
+            <a:avLst/>
+          </a:prstGeom>
+          <a:noFill/>
+        </p:spPr>
+        <p:txBody>
+          <a:bodyPr wrap="square" rtlCol="0">
+            <a:spAutoFit/>
+          </a:bodyPr>
+          <a:lstStyle/>
+          <a:p>
+            <a:r>
+              <a:rPr lang="en-US" sz="1100" dirty="0"/>
+              <a:t>[4] Schneiderhan W, Korpal M, Hinz J, et al. Pancreatic stellate cells are an important source of MMP-2 in human pancreatic cancer and accelerate tumor cell invasion. </a:t>
+            </a:r>
+            <a:r>
+              <a:rPr lang="en-US" sz="1100" i="1" dirty="0"/>
+              <a:t>Gut</a:t>
+            </a:r>
+            <a:r>
+              <a:rPr lang="en-US" sz="1100" dirty="0"/>
+              <a:t>. 2007;56(6):823-830. doi:10.1136/gut.2006.104217</a:t>
+            </a:r>
+            <a:endParaRPr lang="en-US" sz="1100" dirty="0">
+              <a:solidFill>
+                <a:srgbClr val="1B1B1B"/>
+              </a:solidFill>
+              <a:latin typeface="Roboto Mono Web"/>
+            </a:endParaRPr>
+          </a:p>
+          <a:p>
+            <a:endParaRPr lang="en-US" dirty="0"/>
+          </a:p>
+        </p:txBody>
+      </p:sp>
+    </p:spTree>
+    <p:extLst>
+      <p:ext uri="{BB962C8B-B14F-4D97-AF65-F5344CB8AC3E}">
+        <p14:creationId xmlns:p14="http://schemas.microsoft.com/office/powerpoint/2010/main" val="3668296255"/>
+      </p:ext>
+    </p:extLst>
+  </p:cSld>
+  <p:clrMapOvr>
+    <a:masterClrMapping/>
+  </p:clrMapOvr>
+</p:sld>
+</file>
+
+<file path=ppt/slides/slide8.xml><?xml version="1.0" encoding="utf-8"?>
+<p:sld xmlns:a="http://schemas.openxmlformats.org/drawingml/2006/main" xmlns:r="http://schemas.openxmlformats.org/officeDocument/2006/relationships" xmlns:p="http://schemas.openxmlformats.org/presentationml/2006/main">
+  <p:cSld>
+    <p:spTree>
+      <p:nvGrpSpPr>
+        <p:cNvPr id="1" name="">
+          <a:extLst>
+            <a:ext uri="{FF2B5EF4-FFF2-40B4-BE49-F238E27FC236}">
+              <a16:creationId xmlns:a16="http://schemas.microsoft.com/office/drawing/2014/main" id="{16E1487A-FFFE-C060-7FDD-34D3E433B8FD}"/>
+            </a:ext>
+          </a:extLst>
+        </p:cNvPr>
+        <p:cNvGrpSpPr/>
+        <p:nvPr/>
+      </p:nvGrpSpPr>
+      <p:grpSpPr>
+        <a:xfrm>
+          <a:off x="0" y="0"/>
+          <a:ext cx="0" cy="0"/>
+          <a:chOff x="0" y="0"/>
+          <a:chExt cx="0" cy="0"/>
+        </a:xfrm>
+      </p:grpSpPr>
+      <p:sp>
+        <p:nvSpPr>
+          <p:cNvPr id="10" name="Title 9">
+            <a:extLst>
+              <a:ext uri="{FF2B5EF4-FFF2-40B4-BE49-F238E27FC236}">
+                <a16:creationId xmlns:a16="http://schemas.microsoft.com/office/drawing/2014/main" id="{D7E757D7-2538-0610-6B08-436D45D3EF85}"/>
+              </a:ext>
+            </a:extLst>
+          </p:cNvPr>
+          <p:cNvSpPr>
+            <a:spLocks noGrp="1"/>
+          </p:cNvSpPr>
+          <p:nvPr>
+            <p:ph type="title"/>
+          </p:nvPr>
+        </p:nvSpPr>
+        <p:spPr>
+          <a:xfrm>
+            <a:off x="457200" y="331927"/>
+            <a:ext cx="7886700" cy="994172"/>
+          </a:xfrm>
+        </p:spPr>
+        <p:txBody>
+          <a:bodyPr>
+            <a:noAutofit/>
+          </a:bodyPr>
+          <a:lstStyle/>
+          <a:p>
+            <a:r>
+              <a:rPr lang="en-US" sz="3200" b="1" dirty="0">
+                <a:solidFill>
+                  <a:srgbClr val="171C8C"/>
+                </a:solidFill>
+                <a:latin typeface="Arial" panose="020B0604020202020204" pitchFamily="34" charset="0"/>
+                <a:cs typeface="Arial" panose="020B0604020202020204" pitchFamily="34" charset="0"/>
+              </a:rPr>
+              <a:t>Citations</a:t>
+            </a:r>
+          </a:p>
+        </p:txBody>
+      </p:sp>
+      <p:cxnSp>
+        <p:nvCxnSpPr>
+          <p:cNvPr id="5" name="Straight Connector 4">
+            <a:extLst>
+              <a:ext uri="{FF2B5EF4-FFF2-40B4-BE49-F238E27FC236}">
+                <a16:creationId xmlns:a16="http://schemas.microsoft.com/office/drawing/2014/main" id="{277FBDE3-D045-EB92-C9A3-1DAB82684AE3}"/>
               </a:ext>
             </a:extLst>
           </p:cNvPr>
@@ -3489,10 +6884,10 @@
       </p:cxnSp>
       <p:sp>
         <p:nvSpPr>
-          <p:cNvPr id="4" name="TextBox 3">
+          <p:cNvPr id="7" name="TextBox 6">
             <a:extLst>
               <a:ext uri="{FF2B5EF4-FFF2-40B4-BE49-F238E27FC236}">
-                <a16:creationId xmlns:a16="http://schemas.microsoft.com/office/drawing/2014/main" id="{F20D4BC1-E94F-BAA2-9DB2-64545DDBDB52}"/>
+                <a16:creationId xmlns:a16="http://schemas.microsoft.com/office/drawing/2014/main" id="{EB55C810-A69C-9760-96C0-D69C65607F6F}"/>
               </a:ext>
             </a:extLst>
           </p:cNvPr>
@@ -3501,8 +6896,8 @@
         </p:nvSpPr>
         <p:spPr>
           <a:xfrm>
-            <a:off x="457200" y="1717589"/>
-            <a:ext cx="8210811" cy="1938992"/>
+            <a:off x="457199" y="1480498"/>
+            <a:ext cx="8495269" cy="6001643"/>
           </a:xfrm>
           <a:prstGeom prst="rect">
             <a:avLst/>
@@ -3510,93 +6905,211 @@
           <a:noFill/>
         </p:spPr>
         <p:txBody>
-          <a:bodyPr wrap="square" rtlCol="0">
+          <a:bodyPr wrap="square">
             <a:spAutoFit/>
           </a:bodyPr>
           <a:lstStyle/>
           <a:p>
-            <a:pPr marL="342900" indent="-342900">
-              <a:buFont typeface="Arial" panose="020B0604020202020204" pitchFamily="34" charset="0"/>
-              <a:buChar char="•"/>
-            </a:pPr>
-            <a:r>
-              <a:rPr lang="en-US" sz="2400" dirty="0">
+            <a:r>
+              <a:rPr lang="en-US" sz="1600" b="0" i="0" dirty="0">
                 <a:solidFill>
-                  <a:schemeClr val="tx2"/>
+                  <a:srgbClr val="1B1B1B"/>
                 </a:solidFill>
+                <a:effectLst/>
+                <a:latin typeface="Roboto Mono Web"/>
               </a:rPr>
-              <a:t>Review </a:t>
-            </a:r>
-            <a:r>
-              <a:rPr lang="en-US" sz="2400" dirty="0" err="1">
+              <a:t>[1] </a:t>
+            </a:r>
+            <a:r>
+              <a:rPr lang="en-US" sz="1600" b="0" i="0" dirty="0" err="1">
                 <a:solidFill>
-                  <a:schemeClr val="tx2"/>
+                  <a:srgbClr val="1B1B1B"/>
                 </a:solidFill>
+                <a:effectLst/>
+                <a:latin typeface="Roboto Mono Web"/>
               </a:rPr>
-              <a:t>replusive</a:t>
-            </a:r>
-            <a:r>
-              <a:rPr lang="en-US" sz="2400" dirty="0">
+              <a:t>Yurchenco</a:t>
+            </a:r>
+            <a:r>
+              <a:rPr lang="en-US" sz="1600" b="0" i="0" dirty="0">
                 <a:solidFill>
-                  <a:schemeClr val="tx2"/>
+                  <a:srgbClr val="1B1B1B"/>
                 </a:solidFill>
+                <a:effectLst/>
+                <a:latin typeface="Roboto Mono Web"/>
               </a:rPr>
-              <a:t> force. Research alternative mechanic. </a:t>
-            </a:r>
-          </a:p>
-          <a:p>
-            <a:pPr marL="342900" indent="-342900">
-              <a:buFont typeface="Arial" panose="020B0604020202020204" pitchFamily="34" charset="0"/>
-              <a:buChar char="•"/>
-            </a:pPr>
-            <a:endParaRPr lang="en-US" sz="2400" dirty="0">
+              <a:t> PD, Patton BL. Developmental and pathogenic mechanisms of basement membrane assembly. Curr Pharm Des. 2009;15(12):1277-94. </a:t>
+            </a:r>
+            <a:r>
+              <a:rPr lang="en-US" sz="1600" b="0" i="0" dirty="0" err="1">
+                <a:solidFill>
+                  <a:srgbClr val="1B1B1B"/>
+                </a:solidFill>
+                <a:effectLst/>
+                <a:latin typeface="Roboto Mono Web"/>
+              </a:rPr>
+              <a:t>doi</a:t>
+            </a:r>
+            <a:r>
+              <a:rPr lang="en-US" sz="1600" b="0" i="0" dirty="0">
+                <a:solidFill>
+                  <a:srgbClr val="1B1B1B"/>
+                </a:solidFill>
+                <a:effectLst/>
+                <a:latin typeface="Roboto Mono Web"/>
+              </a:rPr>
+              <a:t>: 10.2174/138161209787846766. PMID: 19355968; PMCID: PMC2978668.</a:t>
+            </a:r>
+          </a:p>
+          <a:p>
+            <a:endParaRPr lang="en-US" sz="1600" dirty="0">
               <a:solidFill>
-                <a:schemeClr val="tx2"/>
+                <a:srgbClr val="1B1B1B"/>
               </a:solidFill>
+              <a:latin typeface="Roboto Mono Web"/>
             </a:endParaRPr>
           </a:p>
           <a:p>
-            <a:pPr marL="342900" indent="-342900">
-              <a:buFont typeface="Arial" panose="020B0604020202020204" pitchFamily="34" charset="0"/>
-              <a:buChar char="•"/>
-            </a:pPr>
-            <a:r>
-              <a:rPr lang="en-US" sz="2400" dirty="0">
+            <a:r>
+              <a:rPr lang="en-US" sz="1600" dirty="0"/>
+              <a:t>[2] Guerra </a:t>
+            </a:r>
+            <a:r>
+              <a:rPr lang="en-US" sz="1600" dirty="0" err="1"/>
+              <a:t>Santillán</a:t>
+            </a:r>
+            <a:r>
+              <a:rPr lang="en-US" sz="1600" dirty="0"/>
+              <a:t> KY, </a:t>
+            </a:r>
+            <a:r>
+              <a:rPr lang="en-US" sz="1600" dirty="0" err="1"/>
+              <a:t>Dahmann</a:t>
+            </a:r>
+            <a:r>
+              <a:rPr lang="en-US" sz="1600" dirty="0"/>
+              <a:t> C, Fischer-Friedrich E. Elastic Contractile Stress in the Basement Membrane Generates Basal Tension in Epithelia. PRX Life. 2024;2(1):013004. doi:10.1103/PRXLife.2.013004</a:t>
+            </a:r>
+            <a:endParaRPr lang="en-US" sz="1600" b="0" i="0" dirty="0">
+              <a:solidFill>
+                <a:srgbClr val="1B1B1B"/>
+              </a:solidFill>
+              <a:effectLst/>
+              <a:latin typeface="Roboto Mono Web"/>
+            </a:endParaRPr>
+          </a:p>
+          <a:p>
+            <a:endParaRPr lang="en-US" sz="1600" dirty="0">
+              <a:solidFill>
+                <a:srgbClr val="1B1B1B"/>
+              </a:solidFill>
+              <a:latin typeface="Roboto Mono Web"/>
+            </a:endParaRPr>
+          </a:p>
+          <a:p>
+            <a:r>
+              <a:rPr lang="en-US" sz="1600" dirty="0">
                 <a:solidFill>
-                  <a:schemeClr val="tx2"/>
+                  <a:srgbClr val="1B1B1B"/>
                 </a:solidFill>
+                <a:latin typeface="Roboto Mono Web"/>
               </a:rPr>
-              <a:t>Refine membrane elasticity </a:t>
-            </a:r>
-          </a:p>
-          <a:p>
-            <a:pPr marL="342900" indent="-342900">
-              <a:buFont typeface="Arial" panose="020B0604020202020204" pitchFamily="34" charset="0"/>
-              <a:buChar char="•"/>
-            </a:pPr>
-            <a:endParaRPr lang="en-US" sz="2400" dirty="0">
+              <a:t>[3] H. Li, Y. Zheng, Y.L. Han, S. Cai, &amp; M. Guo, Nonlinear elasticity of biological basement membrane revealed by rapid inflation and deflation, Proc. Natl. Acad. Sci. U.S.A. 118 (11) e2022422118, https://doi.org/10.1073/pnas.2022422118 (2021).</a:t>
+            </a:r>
+          </a:p>
+          <a:p>
+            <a:endParaRPr lang="en-US" sz="1600" dirty="0">
               <a:solidFill>
-                <a:schemeClr val="tx2"/>
+                <a:srgbClr val="1B1B1B"/>
               </a:solidFill>
+              <a:latin typeface="Roboto Mono Web"/>
             </a:endParaRPr>
           </a:p>
           <a:p>
-            <a:pPr marL="342900" indent="-342900">
-              <a:buFont typeface="Arial" panose="020B0604020202020204" pitchFamily="34" charset="0"/>
-              <a:buChar char="•"/>
-            </a:pPr>
-            <a:endParaRPr lang="en-US" sz="2400" dirty="0">
+            <a:r>
+              <a:rPr lang="en-US" sz="1600" dirty="0"/>
+              <a:t>[4] Schneiderhan W, Korpal M, Hinz J, et al. Pancreatic stellate cells are an important source of MMP-2 in human pancreatic cancer and accelerate tumor cell invasion. </a:t>
+            </a:r>
+            <a:r>
+              <a:rPr lang="en-US" sz="1600" i="1" dirty="0"/>
+              <a:t>Gut</a:t>
+            </a:r>
+            <a:r>
+              <a:rPr lang="en-US" sz="1600" dirty="0"/>
+              <a:t>. 2007;56(6):823-830. doi:10.1136/gut.2006.104217</a:t>
+            </a:r>
+            <a:endParaRPr lang="en-US" sz="1600" dirty="0">
               <a:solidFill>
-                <a:schemeClr val="tx2"/>
+                <a:srgbClr val="1B1B1B"/>
               </a:solidFill>
+              <a:latin typeface="Roboto Mono Web"/>
             </a:endParaRPr>
+          </a:p>
+          <a:p>
+            <a:endParaRPr lang="en-US" dirty="0">
+              <a:solidFill>
+                <a:srgbClr val="1B1B1B"/>
+              </a:solidFill>
+              <a:latin typeface="Roboto Mono Web"/>
+            </a:endParaRPr>
+          </a:p>
+          <a:p>
+            <a:endParaRPr lang="en-US" dirty="0">
+              <a:solidFill>
+                <a:srgbClr val="1B1B1B"/>
+              </a:solidFill>
+              <a:latin typeface="Roboto Mono Web"/>
+            </a:endParaRPr>
+          </a:p>
+          <a:p>
+            <a:endParaRPr lang="en-US" dirty="0">
+              <a:solidFill>
+                <a:srgbClr val="1B1B1B"/>
+              </a:solidFill>
+              <a:latin typeface="Roboto Mono Web"/>
+            </a:endParaRPr>
+          </a:p>
+          <a:p>
+            <a:endParaRPr lang="en-US" dirty="0">
+              <a:solidFill>
+                <a:srgbClr val="1B1B1B"/>
+              </a:solidFill>
+              <a:latin typeface="Roboto Mono Web"/>
+            </a:endParaRPr>
+          </a:p>
+          <a:p>
+            <a:endParaRPr lang="en-US" dirty="0">
+              <a:solidFill>
+                <a:srgbClr val="1B1B1B"/>
+              </a:solidFill>
+              <a:latin typeface="Roboto Mono Web"/>
+            </a:endParaRPr>
+          </a:p>
+          <a:p>
+            <a:endParaRPr lang="en-US" dirty="0">
+              <a:solidFill>
+                <a:srgbClr val="1B1B1B"/>
+              </a:solidFill>
+              <a:latin typeface="Roboto Mono Web"/>
+            </a:endParaRPr>
+          </a:p>
+          <a:p>
+            <a:endParaRPr lang="en-US" dirty="0">
+              <a:solidFill>
+                <a:srgbClr val="1B1B1B"/>
+              </a:solidFill>
+              <a:latin typeface="Roboto Mono Web"/>
+            </a:endParaRPr>
+          </a:p>
+          <a:p>
+            <a:endParaRPr lang="en-US" dirty="0"/>
           </a:p>
         </p:txBody>
       </p:sp>
     </p:spTree>
     <p:extLst>
       <p:ext uri="{BB962C8B-B14F-4D97-AF65-F5344CB8AC3E}">
-        <p14:creationId xmlns:p14="http://schemas.microsoft.com/office/powerpoint/2010/main" val="3990933769"/>
+        <p14:creationId xmlns:p14="http://schemas.microsoft.com/office/powerpoint/2010/main" val="3476320439"/>
       </p:ext>
     </p:extLst>
   </p:cSld>

</xml_diff>